<commit_message>
fix: normalize generated module deck footers
Regenerates V06–V12 with one valid footer per slide and adds the V09 grounding visual to the standalone reference deck.
</commit_message>
<xml_diff>
--- a/output/Module02_V08_Updated.pptx
+++ b/output/Module02_V08_Updated.pptx
@@ -3127,15 +3127,13 @@
           </a:bodyPr>
           <a:lstStyle/>
           <a:p>
-            <a:pPr algn="r" rtl="0"/>
+            <a:pPr algn="l" rtl="0"/>
             <a:r>
               <a:rPr sz="2800" b="1">
                 <a:solidFill>
                   <a:srgbClr val="1F4E79"/>
                 </a:solidFill>
                 <a:latin typeface="Calibri"/>
-                <a:cs typeface="Arial"/>
-                <a:ea typeface="Calibri"/>
               </a:rPr>
               <a:t>Module 02  |  V08</a:t>
             </a:r>
@@ -3171,8 +3169,6 @@
                   <a:srgbClr val="1F3B5C"/>
                 </a:solidFill>
                 <a:latin typeface="Arial"/>
-                <a:cs typeface="Arial"/>
-                <a:ea typeface="Calibri"/>
               </a:rPr>
               <a:t>هندسة الخصائص ومخازنها</a:t>
             </a:r>
@@ -3201,15 +3197,13 @@
           </a:bodyPr>
           <a:lstStyle/>
           <a:p>
-            <a:pPr algn="r" rtl="0"/>
+            <a:pPr algn="l" rtl="0"/>
             <a:r>
               <a:rPr sz="3000" b="0">
                 <a:solidFill>
                   <a:srgbClr val="333333"/>
                 </a:solidFill>
                 <a:latin typeface="Calibri"/>
-                <a:cs typeface="Arial"/>
-                <a:ea typeface="Calibri"/>
               </a:rPr>
               <a:t>Feature Engineering &amp; Feature Stores</a:t>
             </a:r>
@@ -3218,14 +3212,14 @@
       </p:sp>
       <p:sp>
         <p:nvSpPr>
-          <p:cNvPr id="5" name="TextBox 4"/>
+          <p:cNvPr id="6" name="TextBox 5"/>
           <p:cNvSpPr txBox="1"/>
           <p:nvPr/>
         </p:nvSpPr>
         <p:spPr>
           <a:xfrm>
-            <a:off x="822960" y="4937760"/>
-            <a:ext cx="10515600" cy="548640"/>
+            <a:off x="822960" y="5486400"/>
+            <a:ext cx="10515600" cy="457200"/>
           </a:xfrm>
           <a:prstGeom prst="rect">
             <a:avLst/>
@@ -3238,31 +3232,29 @@
           </a:bodyPr>
           <a:lstStyle/>
           <a:p>
-            <a:pPr algn="r" rtl="1"/>
-            <a:r>
-              <a:rPr sz="1800" b="0">
+            <a:pPr algn="l" rtl="0"/>
+            <a:r>
+              <a:rPr sz="1400" b="0">
                 <a:solidFill>
                   <a:srgbClr val="666666"/>
                 </a:solidFill>
-                <a:latin typeface="Arial"/>
-                <a:cs typeface="Arial"/>
-                <a:ea typeface="Calibri"/>
-              </a:rPr>
-              <a:t>Module 02 — Data &amp; AI Engineering Track  |  الوحدة الثانية</a:t>
-            </a:r>
-          </a:p>
-        </p:txBody>
-      </p:sp>
-      <p:sp>
-        <p:nvSpPr>
-          <p:cNvPr id="6" name="TextBox 5"/>
+                <a:latin typeface="Calibri"/>
+              </a:rPr>
+              <a:t>Light theme  |  Bilingual AR/EN  |  Ready to present</a:t>
+            </a:r>
+          </a:p>
+        </p:txBody>
+      </p:sp>
+      <p:sp>
+        <p:nvSpPr>
+          <p:cNvPr id="7" name="TextBox 6"/>
           <p:cNvSpPr txBox="1"/>
           <p:nvPr/>
         </p:nvSpPr>
         <p:spPr>
           <a:xfrm>
-            <a:off x="822960" y="5486400"/>
-            <a:ext cx="10515600" cy="457200"/>
+            <a:off x="640080" y="6400800"/>
+            <a:ext cx="8686800" cy="320040"/>
           </a:xfrm>
           <a:prstGeom prst="rect">
             <a:avLst/>
@@ -3275,31 +3267,29 @@
           </a:bodyPr>
           <a:lstStyle/>
           <a:p>
-            <a:pPr algn="r" rtl="0"/>
-            <a:r>
-              <a:rPr sz="1400" b="0">
+            <a:pPr algn="r" rtl="1"/>
+            <a:r>
+              <a:rPr sz="1000" b="0">
                 <a:solidFill>
                   <a:srgbClr val="666666"/>
                 </a:solidFill>
-                <a:latin typeface="Calibri"/>
-                <a:cs typeface="Arial"/>
-                <a:ea typeface="Calibri"/>
-              </a:rPr>
-              <a:t>Light theme  |  Bilingual AR/EN  |  Ready to present</a:t>
-            </a:r>
-          </a:p>
-        </p:txBody>
-      </p:sp>
-      <p:sp>
-        <p:nvSpPr>
-          <p:cNvPr id="7" name="TextBox 6"/>
+                <a:latin typeface="Arial"/>
+              </a:rPr>
+              <a:t>Module 02 — Data &amp; AI Engineering Track  |  الوحدة الثانية</a:t>
+            </a:r>
+          </a:p>
+        </p:txBody>
+      </p:sp>
+      <p:sp>
+        <p:nvSpPr>
+          <p:cNvPr id="8" name="TextBox 7"/>
           <p:cNvSpPr txBox="1"/>
           <p:nvPr/>
         </p:nvSpPr>
         <p:spPr>
           <a:xfrm>
-            <a:off x="640080" y="6400800"/>
-            <a:ext cx="8686800" cy="320040"/>
+            <a:off x="9601200" y="6400800"/>
+            <a:ext cx="1920240" cy="320040"/>
           </a:xfrm>
           <a:prstGeom prst="rect">
             <a:avLst/>
@@ -3312,202 +3302,15 @@
           </a:bodyPr>
           <a:lstStyle/>
           <a:p>
-            <a:pPr algn="r" rtl="1"/>
+            <a:pPr algn="l" rtl="0"/>
             <a:r>
               <a:rPr sz="1000" b="0">
                 <a:solidFill>
                   <a:srgbClr val="666666"/>
                 </a:solidFill>
-                <a:latin typeface="Arial"/>
-                <a:cs typeface="Arial"/>
-                <a:ea typeface="Calibri"/>
-              </a:rPr>
-              <a:t>Module 02 — Data &amp; AI Engineering Track  |  الوحدة الثانية</a:t>
-            </a:r>
-          </a:p>
-        </p:txBody>
-      </p:sp>
-      <p:sp>
-        <p:nvSpPr>
-          <p:cNvPr id="8" name="TextBox 7"/>
-          <p:cNvSpPr txBox="1"/>
-          <p:nvPr/>
-        </p:nvSpPr>
-        <p:spPr>
-          <a:xfrm>
-            <a:off x="9601200" y="6400800"/>
-            <a:ext cx="1920240" cy="320040"/>
-          </a:xfrm>
-          <a:prstGeom prst="rect">
-            <a:avLst/>
-          </a:prstGeom>
-          <a:noFill/>
-        </p:spPr>
-        <p:txBody>
-          <a:bodyPr wrap="square">
-            <a:spAutoFit/>
-          </a:bodyPr>
-          <a:lstStyle/>
-          <a:p>
-            <a:pPr algn="l" rtl="0"/>
-            <a:r>
-              <a:rPr sz="1000" b="0">
-                <a:solidFill>
-                  <a:srgbClr val="666666"/>
-                </a:solidFill>
                 <a:latin typeface="Calibri"/>
-                <a:cs typeface="Arial"/>
-                <a:ea typeface="Calibri"/>
-              </a:rPr>
-              <a:t>V08  •  1/12</a:t>
-            </a:r>
-          </a:p>
-        </p:txBody>
-      </p:sp>
-      <p:sp>
-        <p:nvSpPr>
-          <p:cNvPr id="9" name="TextBox 8"/>
-          <p:cNvSpPr txBox="1"/>
-          <p:nvPr/>
-        </p:nvSpPr>
-        <p:spPr>
-          <a:xfrm>
-            <a:off x="640080" y="6400800"/>
-            <a:ext cx="8686800" cy="320040"/>
-          </a:xfrm>
-          <a:prstGeom prst="rect">
-            <a:avLst/>
-          </a:prstGeom>
-          <a:noFill/>
-        </p:spPr>
-        <p:txBody>
-          <a:bodyPr wrap="square">
-            <a:spAutoFit/>
-          </a:bodyPr>
-          <a:lstStyle/>
-          <a:p>
-            <a:pPr algn="r" rtl="1"/>
-            <a:r>
-              <a:rPr sz="1000" b="0">
-                <a:solidFill>
-                  <a:srgbClr val="666666"/>
-                </a:solidFill>
-                <a:latin typeface="Arial"/>
-                <a:cs typeface="Arial"/>
-                <a:ea typeface="Calibri"/>
-              </a:rPr>
-              <a:t>Module 02 — Data &amp; AI Engineering Track  |  الوحدة الثانية</a:t>
-            </a:r>
-          </a:p>
-        </p:txBody>
-      </p:sp>
-      <p:sp>
-        <p:nvSpPr>
-          <p:cNvPr id="10" name="TextBox 9"/>
-          <p:cNvSpPr txBox="1"/>
-          <p:nvPr/>
-        </p:nvSpPr>
-        <p:spPr>
-          <a:xfrm>
-            <a:off x="9601200" y="6400800"/>
-            <a:ext cx="1920240" cy="320040"/>
-          </a:xfrm>
-          <a:prstGeom prst="rect">
-            <a:avLst/>
-          </a:prstGeom>
-          <a:noFill/>
-        </p:spPr>
-        <p:txBody>
-          <a:bodyPr wrap="square">
-            <a:spAutoFit/>
-          </a:bodyPr>
-          <a:lstStyle/>
-          <a:p>
-            <a:pPr algn="l" rtl="0"/>
-            <a:r>
-              <a:rPr sz="1000" b="0">
-                <a:solidFill>
-                  <a:srgbClr val="666666"/>
-                </a:solidFill>
-                <a:latin typeface="Calibri"/>
-                <a:cs typeface="Arial"/>
-                <a:ea typeface="Calibri"/>
-              </a:rPr>
-              <a:t>08_  •  1/10</a:t>
-            </a:r>
-          </a:p>
-        </p:txBody>
-      </p:sp>
-      <p:sp>
-        <p:nvSpPr>
-          <p:cNvPr id="11" name="TextBox 10"/>
-          <p:cNvSpPr txBox="1"/>
-          <p:nvPr/>
-        </p:nvSpPr>
-        <p:spPr>
-          <a:xfrm>
-            <a:off x="640080" y="6400800"/>
-            <a:ext cx="8686800" cy="320040"/>
-          </a:xfrm>
-          <a:prstGeom prst="rect">
-            <a:avLst/>
-          </a:prstGeom>
-          <a:noFill/>
-        </p:spPr>
-        <p:txBody>
-          <a:bodyPr wrap="square">
-            <a:spAutoFit/>
-          </a:bodyPr>
-          <a:lstStyle/>
-          <a:p>
-            <a:pPr algn="r" rtl="1"/>
-            <a:r>
-              <a:rPr sz="1000" b="0">
-                <a:solidFill>
-                  <a:srgbClr val="666666"/>
-                </a:solidFill>
-                <a:latin typeface="Arial"/>
-                <a:cs typeface="Arial"/>
-                <a:ea typeface="Calibri"/>
-              </a:rPr>
-              <a:t>Module 02 — Data &amp; AI Engineering Track  |  الوحدة الثانية</a:t>
-            </a:r>
-          </a:p>
-        </p:txBody>
-      </p:sp>
-      <p:sp>
-        <p:nvSpPr>
-          <p:cNvPr id="12" name="TextBox 11"/>
-          <p:cNvSpPr txBox="1"/>
-          <p:nvPr/>
-        </p:nvSpPr>
-        <p:spPr>
-          <a:xfrm>
-            <a:off x="9601200" y="6400800"/>
-            <a:ext cx="1920240" cy="320040"/>
-          </a:xfrm>
-          <a:prstGeom prst="rect">
-            <a:avLst/>
-          </a:prstGeom>
-          <a:noFill/>
-        </p:spPr>
-        <p:txBody>
-          <a:bodyPr wrap="square">
-            <a:spAutoFit/>
-          </a:bodyPr>
-          <a:lstStyle/>
-          <a:p>
-            <a:pPr algn="l" rtl="0"/>
-            <a:r>
-              <a:rPr sz="1000" b="0">
-                <a:solidFill>
-                  <a:srgbClr val="666666"/>
-                </a:solidFill>
-                <a:latin typeface="Calibri"/>
-                <a:cs typeface="Arial"/>
-                <a:ea typeface="Calibri"/>
-              </a:rPr>
-              <a:t>08_  •  1/10</a:t>
+              </a:rPr>
+              <a:t>V08  •  1/10</a:t>
             </a:r>
           </a:p>
         </p:txBody>
@@ -3540,22 +3343,57 @@
       <p:grpSpPr/>
       <p:sp>
         <p:nvSpPr>
-          <p:cNvPr id="2" name="Rectangle 1"/>
-          <p:cNvSpPr/>
+          <p:cNvPr id="2" name="TextBox 1"/>
+          <p:cNvSpPr txBox="1"/>
           <p:nvPr/>
         </p:nvSpPr>
         <p:spPr>
           <a:xfrm>
-            <a:off x="0" y="0"/>
-            <a:ext cx="12191695" cy="1005840"/>
+            <a:off x="640080" y="137160"/>
+            <a:ext cx="10972800" cy="640080"/>
           </a:xfrm>
           <a:prstGeom prst="rect">
             <a:avLst/>
           </a:prstGeom>
+          <a:noFill/>
+        </p:spPr>
+        <p:txBody>
+          <a:bodyPr wrap="none">
+            <a:spAutoFit/>
+          </a:bodyPr>
+          <a:lstStyle/>
+          <a:p>
+            <a:pPr algn="r" rtl="1"/>
+            <a:r>
+              <a:rPr sz="3000" b="1">
+                <a:solidFill>
+                  <a:srgbClr val="1F3B5C"/>
+                </a:solidFill>
+                <a:latin typeface="Arial"/>
+              </a:rPr>
+              <a:t>معمارية مخزن الخصائص / Feature Store Architecture</a:t>
+            </a:r>
+          </a:p>
+        </p:txBody>
+      </p:sp>
+      <p:sp>
+        <p:nvSpPr>
+          <p:cNvPr id="3" name="Rounded Rectangle 2"/>
+          <p:cNvSpPr/>
+          <p:nvPr/>
+        </p:nvSpPr>
+        <p:spPr>
+          <a:xfrm>
+            <a:off x="640080" y="2560320"/>
+            <a:ext cx="2011680" cy="1188720"/>
+          </a:xfrm>
+          <a:prstGeom prst="roundRect">
+            <a:avLst/>
+          </a:prstGeom>
           <a:solidFill>
-            <a:srgbClr val="FFFFFF"/>
+            <a:srgbClr val="EDEDED"/>
           </a:solidFill>
-          <a:ln w="25400">
+          <a:ln w="12700">
             <a:solidFill>
               <a:srgbClr val="1F4E79"/>
             </a:solidFill>
@@ -3577,6 +3415,71 @@
           </a:fontRef>
         </p:style>
         <p:txBody>
+          <a:bodyPr rtlCol="0" anchor="ctr" wrap="square"/>
+          <a:lstStyle/>
+          <a:p>
+            <a:pPr algn="ctr" rtl="1"/>
+            <a:r>
+              <a:rPr sz="1400" b="1">
+                <a:solidFill>
+                  <a:srgbClr val="333333"/>
+                </a:solidFill>
+                <a:latin typeface="Arial"/>
+              </a:rPr>
+              <a:t>مصادر البيانات</a:t>
+            </a:r>
+          </a:p>
+          <a:p>
+            <a:pPr algn="ctr" rtl="0"/>
+            <a:r>
+              <a:rPr sz="1100">
+                <a:solidFill>
+                  <a:srgbClr val="666666"/>
+                </a:solidFill>
+                <a:latin typeface="Calibri"/>
+              </a:rPr>
+              <a:t>Data Sources</a:t>
+            </a:r>
+          </a:p>
+        </p:txBody>
+      </p:sp>
+      <p:sp>
+        <p:nvSpPr>
+          <p:cNvPr id="4" name="Left Arrow 3"/>
+          <p:cNvSpPr/>
+          <p:nvPr/>
+        </p:nvSpPr>
+        <p:spPr>
+          <a:xfrm>
+            <a:off x="2724912" y="3017520"/>
+            <a:ext cx="411480" cy="274320"/>
+          </a:xfrm>
+          <a:prstGeom prst="leftArrow">
+            <a:avLst/>
+          </a:prstGeom>
+          <a:solidFill>
+            <a:srgbClr val="1F4E79"/>
+          </a:solidFill>
+          <a:ln>
+            <a:noFill/>
+          </a:ln>
+          <a:effectLst/>
+        </p:spPr>
+        <p:style>
+          <a:lnRef idx="1">
+            <a:schemeClr val="accent1"/>
+          </a:lnRef>
+          <a:fillRef idx="3">
+            <a:schemeClr val="accent1"/>
+          </a:fillRef>
+          <a:effectRef idx="2">
+            <a:schemeClr val="accent1"/>
+          </a:effectRef>
+          <a:fontRef idx="minor">
+            <a:schemeClr val="lt1"/>
+          </a:fontRef>
+        </p:style>
+        <p:txBody>
           <a:bodyPr rtlCol="0" anchor="ctr"/>
           <a:lstStyle/>
           <a:p>
@@ -3586,14 +3489,528 @@
       </p:sp>
       <p:sp>
         <p:nvSpPr>
-          <p:cNvPr id="3" name="TextBox 2"/>
+          <p:cNvPr id="5" name="Rounded Rectangle 4"/>
+          <p:cNvSpPr/>
+          <p:nvPr/>
+        </p:nvSpPr>
+        <p:spPr>
+          <a:xfrm>
+            <a:off x="3200400" y="2560320"/>
+            <a:ext cx="2194560" cy="1188720"/>
+          </a:xfrm>
+          <a:prstGeom prst="roundRect">
+            <a:avLst/>
+          </a:prstGeom>
+          <a:solidFill>
+            <a:srgbClr val="DCE6F1"/>
+          </a:solidFill>
+          <a:ln w="12700">
+            <a:solidFill>
+              <a:srgbClr val="1F4E79"/>
+            </a:solidFill>
+          </a:ln>
+          <a:effectLst/>
+        </p:spPr>
+        <p:style>
+          <a:lnRef idx="1">
+            <a:schemeClr val="accent1"/>
+          </a:lnRef>
+          <a:fillRef idx="3">
+            <a:schemeClr val="accent1"/>
+          </a:fillRef>
+          <a:effectRef idx="2">
+            <a:schemeClr val="accent1"/>
+          </a:effectRef>
+          <a:fontRef idx="minor">
+            <a:schemeClr val="lt1"/>
+          </a:fontRef>
+        </p:style>
+        <p:txBody>
+          <a:bodyPr rtlCol="0" anchor="ctr" wrap="square"/>
+          <a:lstStyle/>
+          <a:p>
+            <a:pPr algn="ctr" rtl="1"/>
+            <a:r>
+              <a:rPr sz="1400" b="1">
+                <a:solidFill>
+                  <a:srgbClr val="333333"/>
+                </a:solidFill>
+                <a:latin typeface="Arial"/>
+              </a:rPr>
+              <a:t>خط الخصائص</a:t>
+            </a:r>
+          </a:p>
+          <a:p>
+            <a:pPr algn="ctr" rtl="0"/>
+            <a:r>
+              <a:rPr sz="1100">
+                <a:solidFill>
+                  <a:srgbClr val="666666"/>
+                </a:solidFill>
+                <a:latin typeface="Calibri"/>
+              </a:rPr>
+              <a:t>Feature Pipeline
+هندسة + تحويل</a:t>
+            </a:r>
+          </a:p>
+        </p:txBody>
+      </p:sp>
+      <p:sp>
+        <p:nvSpPr>
+          <p:cNvPr id="6" name="Left Arrow 5"/>
+          <p:cNvSpPr/>
+          <p:nvPr/>
+        </p:nvSpPr>
+        <p:spPr>
+          <a:xfrm>
+            <a:off x="5468112" y="2331720"/>
+            <a:ext cx="411480" cy="274320"/>
+          </a:xfrm>
+          <a:prstGeom prst="leftArrow">
+            <a:avLst/>
+          </a:prstGeom>
+          <a:solidFill>
+            <a:srgbClr val="1F4E79"/>
+          </a:solidFill>
+          <a:ln>
+            <a:noFill/>
+          </a:ln>
+          <a:effectLst/>
+        </p:spPr>
+        <p:style>
+          <a:lnRef idx="1">
+            <a:schemeClr val="accent1"/>
+          </a:lnRef>
+          <a:fillRef idx="3">
+            <a:schemeClr val="accent1"/>
+          </a:fillRef>
+          <a:effectRef idx="2">
+            <a:schemeClr val="accent1"/>
+          </a:effectRef>
+          <a:fontRef idx="minor">
+            <a:schemeClr val="lt1"/>
+          </a:fontRef>
+        </p:style>
+        <p:txBody>
+          <a:bodyPr rtlCol="0" anchor="ctr"/>
+          <a:lstStyle/>
+          <a:p>
+            <a:pPr algn="ctr"/>
+          </a:p>
+        </p:txBody>
+      </p:sp>
+      <p:sp>
+        <p:nvSpPr>
+          <p:cNvPr id="7" name="Left Arrow 6"/>
+          <p:cNvSpPr/>
+          <p:nvPr/>
+        </p:nvSpPr>
+        <p:spPr>
+          <a:xfrm>
+            <a:off x="5468112" y="3611880"/>
+            <a:ext cx="411480" cy="274320"/>
+          </a:xfrm>
+          <a:prstGeom prst="leftArrow">
+            <a:avLst/>
+          </a:prstGeom>
+          <a:solidFill>
+            <a:srgbClr val="1F4E79"/>
+          </a:solidFill>
+          <a:ln>
+            <a:noFill/>
+          </a:ln>
+          <a:effectLst/>
+        </p:spPr>
+        <p:style>
+          <a:lnRef idx="1">
+            <a:schemeClr val="accent1"/>
+          </a:lnRef>
+          <a:fillRef idx="3">
+            <a:schemeClr val="accent1"/>
+          </a:fillRef>
+          <a:effectRef idx="2">
+            <a:schemeClr val="accent1"/>
+          </a:effectRef>
+          <a:fontRef idx="minor">
+            <a:schemeClr val="lt1"/>
+          </a:fontRef>
+        </p:style>
+        <p:txBody>
+          <a:bodyPr rtlCol="0" anchor="ctr"/>
+          <a:lstStyle/>
+          <a:p>
+            <a:pPr algn="ctr"/>
+          </a:p>
+        </p:txBody>
+      </p:sp>
+      <p:sp>
+        <p:nvSpPr>
+          <p:cNvPr id="8" name="Rounded Rectangle 7"/>
+          <p:cNvSpPr/>
+          <p:nvPr/>
+        </p:nvSpPr>
+        <p:spPr>
+          <a:xfrm>
+            <a:off x="5943600" y="1554480"/>
+            <a:ext cx="2468880" cy="1188720"/>
+          </a:xfrm>
+          <a:prstGeom prst="roundRect">
+            <a:avLst/>
+          </a:prstGeom>
+          <a:solidFill>
+            <a:srgbClr val="E2EFDA"/>
+          </a:solidFill>
+          <a:ln w="12700">
+            <a:solidFill>
+              <a:srgbClr val="1F4E79"/>
+            </a:solidFill>
+          </a:ln>
+          <a:effectLst/>
+        </p:spPr>
+        <p:style>
+          <a:lnRef idx="1">
+            <a:schemeClr val="accent1"/>
+          </a:lnRef>
+          <a:fillRef idx="3">
+            <a:schemeClr val="accent1"/>
+          </a:fillRef>
+          <a:effectRef idx="2">
+            <a:schemeClr val="accent1"/>
+          </a:effectRef>
+          <a:fontRef idx="minor">
+            <a:schemeClr val="lt1"/>
+          </a:fontRef>
+        </p:style>
+        <p:txBody>
+          <a:bodyPr rtlCol="0" anchor="ctr" wrap="square"/>
+          <a:lstStyle/>
+          <a:p>
+            <a:pPr algn="ctr" rtl="1"/>
+            <a:r>
+              <a:rPr sz="1300" b="1">
+                <a:solidFill>
+                  <a:srgbClr val="333333"/>
+                </a:solidFill>
+                <a:latin typeface="Arial"/>
+              </a:rPr>
+              <a:t>المخزن غير المتصل</a:t>
+            </a:r>
+          </a:p>
+          <a:p>
+            <a:pPr algn="ctr" rtl="0"/>
+            <a:r>
+              <a:rPr sz="1100">
+                <a:solidFill>
+                  <a:srgbClr val="666666"/>
+                </a:solidFill>
+                <a:latin typeface="Calibri"/>
+              </a:rPr>
+              <a:t>Offline Store
+تدريب النماذج</a:t>
+            </a:r>
+          </a:p>
+        </p:txBody>
+      </p:sp>
+      <p:sp>
+        <p:nvSpPr>
+          <p:cNvPr id="9" name="Rounded Rectangle 8"/>
+          <p:cNvSpPr/>
+          <p:nvPr/>
+        </p:nvSpPr>
+        <p:spPr>
+          <a:xfrm>
+            <a:off x="5943600" y="3566160"/>
+            <a:ext cx="2468880" cy="1188720"/>
+          </a:xfrm>
+          <a:prstGeom prst="roundRect">
+            <a:avLst/>
+          </a:prstGeom>
+          <a:solidFill>
+            <a:srgbClr val="FDE9D9"/>
+          </a:solidFill>
+          <a:ln w="12700">
+            <a:solidFill>
+              <a:srgbClr val="1F4E79"/>
+            </a:solidFill>
+          </a:ln>
+          <a:effectLst/>
+        </p:spPr>
+        <p:style>
+          <a:lnRef idx="1">
+            <a:schemeClr val="accent1"/>
+          </a:lnRef>
+          <a:fillRef idx="3">
+            <a:schemeClr val="accent1"/>
+          </a:fillRef>
+          <a:effectRef idx="2">
+            <a:schemeClr val="accent1"/>
+          </a:effectRef>
+          <a:fontRef idx="minor">
+            <a:schemeClr val="lt1"/>
+          </a:fontRef>
+        </p:style>
+        <p:txBody>
+          <a:bodyPr rtlCol="0" anchor="ctr" wrap="square"/>
+          <a:lstStyle/>
+          <a:p>
+            <a:pPr algn="ctr" rtl="1"/>
+            <a:r>
+              <a:rPr sz="1300" b="1">
+                <a:solidFill>
+                  <a:srgbClr val="333333"/>
+                </a:solidFill>
+                <a:latin typeface="Arial"/>
+              </a:rPr>
+              <a:t>المخزن المتصل</a:t>
+            </a:r>
+          </a:p>
+          <a:p>
+            <a:pPr algn="ctr" rtl="0"/>
+            <a:r>
+              <a:rPr sz="1100">
+                <a:solidFill>
+                  <a:srgbClr val="666666"/>
+                </a:solidFill>
+                <a:latin typeface="Calibri"/>
+              </a:rPr>
+              <a:t>Online Store
+استدلال منخفض زمن الاستجابة</a:t>
+            </a:r>
+          </a:p>
+        </p:txBody>
+      </p:sp>
+      <p:sp>
+        <p:nvSpPr>
+          <p:cNvPr id="10" name="Rounded Rectangle 9"/>
+          <p:cNvSpPr/>
+          <p:nvPr/>
+        </p:nvSpPr>
+        <p:spPr>
+          <a:xfrm>
+            <a:off x="9144000" y="1554480"/>
+            <a:ext cx="2194560" cy="1188720"/>
+          </a:xfrm>
+          <a:prstGeom prst="roundRect">
+            <a:avLst/>
+          </a:prstGeom>
+          <a:solidFill>
+            <a:srgbClr val="EDEDED"/>
+          </a:solidFill>
+          <a:ln w="12700">
+            <a:solidFill>
+              <a:srgbClr val="1F4E79"/>
+            </a:solidFill>
+          </a:ln>
+          <a:effectLst/>
+        </p:spPr>
+        <p:style>
+          <a:lnRef idx="1">
+            <a:schemeClr val="accent1"/>
+          </a:lnRef>
+          <a:fillRef idx="3">
+            <a:schemeClr val="accent1"/>
+          </a:fillRef>
+          <a:effectRef idx="2">
+            <a:schemeClr val="accent1"/>
+          </a:effectRef>
+          <a:fontRef idx="minor">
+            <a:schemeClr val="lt1"/>
+          </a:fontRef>
+        </p:style>
+        <p:txBody>
+          <a:bodyPr rtlCol="0" anchor="ctr" wrap="square"/>
+          <a:lstStyle/>
+          <a:p>
+            <a:pPr algn="ctr" rtl="1"/>
+            <a:r>
+              <a:rPr sz="1400" b="1">
+                <a:solidFill>
+                  <a:srgbClr val="333333"/>
+                </a:solidFill>
+                <a:latin typeface="Arial"/>
+              </a:rPr>
+              <a:t>التدريب</a:t>
+            </a:r>
+          </a:p>
+          <a:p>
+            <a:pPr algn="ctr" rtl="0"/>
+            <a:r>
+              <a:rPr sz="1100">
+                <a:solidFill>
+                  <a:srgbClr val="666666"/>
+                </a:solidFill>
+                <a:latin typeface="Calibri"/>
+              </a:rPr>
+              <a:t>Training</a:t>
+            </a:r>
+          </a:p>
+        </p:txBody>
+      </p:sp>
+      <p:sp>
+        <p:nvSpPr>
+          <p:cNvPr id="11" name="Rounded Rectangle 10"/>
+          <p:cNvSpPr/>
+          <p:nvPr/>
+        </p:nvSpPr>
+        <p:spPr>
+          <a:xfrm>
+            <a:off x="9144000" y="3566160"/>
+            <a:ext cx="2194560" cy="1188720"/>
+          </a:xfrm>
+          <a:prstGeom prst="roundRect">
+            <a:avLst/>
+          </a:prstGeom>
+          <a:solidFill>
+            <a:srgbClr val="EDEDED"/>
+          </a:solidFill>
+          <a:ln w="12700">
+            <a:solidFill>
+              <a:srgbClr val="1F4E79"/>
+            </a:solidFill>
+          </a:ln>
+          <a:effectLst/>
+        </p:spPr>
+        <p:style>
+          <a:lnRef idx="1">
+            <a:schemeClr val="accent1"/>
+          </a:lnRef>
+          <a:fillRef idx="3">
+            <a:schemeClr val="accent1"/>
+          </a:fillRef>
+          <a:effectRef idx="2">
+            <a:schemeClr val="accent1"/>
+          </a:effectRef>
+          <a:fontRef idx="minor">
+            <a:schemeClr val="lt1"/>
+          </a:fontRef>
+        </p:style>
+        <p:txBody>
+          <a:bodyPr rtlCol="0" anchor="ctr" wrap="square"/>
+          <a:lstStyle/>
+          <a:p>
+            <a:pPr algn="ctr" rtl="1"/>
+            <a:r>
+              <a:rPr sz="1400" b="1">
+                <a:solidFill>
+                  <a:srgbClr val="333333"/>
+                </a:solidFill>
+                <a:latin typeface="Arial"/>
+              </a:rPr>
+              <a:t>الاستدلال</a:t>
+            </a:r>
+          </a:p>
+          <a:p>
+            <a:pPr algn="ctr" rtl="0"/>
+            <a:r>
+              <a:rPr sz="1100">
+                <a:solidFill>
+                  <a:srgbClr val="666666"/>
+                </a:solidFill>
+                <a:latin typeface="Calibri"/>
+              </a:rPr>
+              <a:t>Serving</a:t>
+            </a:r>
+          </a:p>
+        </p:txBody>
+      </p:sp>
+      <p:sp>
+        <p:nvSpPr>
+          <p:cNvPr id="12" name="Left Arrow 11"/>
+          <p:cNvSpPr/>
+          <p:nvPr/>
+        </p:nvSpPr>
+        <p:spPr>
+          <a:xfrm>
+            <a:off x="8449056" y="2011680"/>
+            <a:ext cx="658368" cy="274320"/>
+          </a:xfrm>
+          <a:prstGeom prst="leftArrow">
+            <a:avLst/>
+          </a:prstGeom>
+          <a:solidFill>
+            <a:srgbClr val="1F4E79"/>
+          </a:solidFill>
+          <a:ln>
+            <a:noFill/>
+          </a:ln>
+          <a:effectLst/>
+        </p:spPr>
+        <p:style>
+          <a:lnRef idx="1">
+            <a:schemeClr val="accent1"/>
+          </a:lnRef>
+          <a:fillRef idx="3">
+            <a:schemeClr val="accent1"/>
+          </a:fillRef>
+          <a:effectRef idx="2">
+            <a:schemeClr val="accent1"/>
+          </a:effectRef>
+          <a:fontRef idx="minor">
+            <a:schemeClr val="lt1"/>
+          </a:fontRef>
+        </p:style>
+        <p:txBody>
+          <a:bodyPr rtlCol="0" anchor="ctr"/>
+          <a:lstStyle/>
+          <a:p>
+            <a:pPr algn="ctr"/>
+          </a:p>
+        </p:txBody>
+      </p:sp>
+      <p:sp>
+        <p:nvSpPr>
+          <p:cNvPr id="13" name="Left Arrow 12"/>
+          <p:cNvSpPr/>
+          <p:nvPr/>
+        </p:nvSpPr>
+        <p:spPr>
+          <a:xfrm>
+            <a:off x="8449056" y="4023360"/>
+            <a:ext cx="658368" cy="274320"/>
+          </a:xfrm>
+          <a:prstGeom prst="leftArrow">
+            <a:avLst/>
+          </a:prstGeom>
+          <a:solidFill>
+            <a:srgbClr val="1F4E79"/>
+          </a:solidFill>
+          <a:ln>
+            <a:noFill/>
+          </a:ln>
+          <a:effectLst/>
+        </p:spPr>
+        <p:style>
+          <a:lnRef idx="1">
+            <a:schemeClr val="accent1"/>
+          </a:lnRef>
+          <a:fillRef idx="3">
+            <a:schemeClr val="accent1"/>
+          </a:fillRef>
+          <a:effectRef idx="2">
+            <a:schemeClr val="accent1"/>
+          </a:effectRef>
+          <a:fontRef idx="minor">
+            <a:schemeClr val="lt1"/>
+          </a:fontRef>
+        </p:style>
+        <p:txBody>
+          <a:bodyPr rtlCol="0" anchor="ctr"/>
+          <a:lstStyle/>
+          <a:p>
+            <a:pPr algn="ctr"/>
+          </a:p>
+        </p:txBody>
+      </p:sp>
+      <p:sp>
+        <p:nvSpPr>
+          <p:cNvPr id="14" name="TextBox 13"/>
           <p:cNvSpPr txBox="1"/>
           <p:nvPr/>
         </p:nvSpPr>
         <p:spPr>
           <a:xfrm>
-            <a:off x="640080" y="182880"/>
-            <a:ext cx="10972800" cy="640080"/>
+            <a:off x="640080" y="6126480"/>
+            <a:ext cx="10972800" cy="548640"/>
           </a:xfrm>
           <a:prstGeom prst="rect">
             <a:avLst/>
@@ -3608,29 +4025,33 @@
           <a:p>
             <a:pPr algn="r" rtl="1"/>
             <a:r>
-              <a:rPr sz="3200" b="1">
-                <a:solidFill>
-                  <a:srgbClr val="1F3B5C"/>
+              <a:rPr sz="1400">
+                <a:solidFill>
+                  <a:srgbClr val="666666"/>
                 </a:solidFill>
                 <a:latin typeface="Arial"/>
-                <a:cs typeface="Arial"/>
-                <a:ea typeface="Calibri"/>
-              </a:rPr>
-              <a:t>للاستزادة / Further Reading</a:t>
-            </a:r>
-          </a:p>
-        </p:txBody>
-      </p:sp>
-      <p:sp>
-        <p:nvSpPr>
-          <p:cNvPr id="4" name="TextBox 3"/>
+              </a:rPr>
+              <a:t>قيمة مخزن الخصائص: نفس تعريف الخصائص للتدريب والاستدلال — لا انحراف.</a:t>
+            </a:r>
+          </a:p>
+          <a:p>
+            <a:pPr algn="r" rtl="0"/>
+            <a:r>
+              <a:t>Core value: one feature definition for training and serving — no skew.</a:t>
+            </a:r>
+          </a:p>
+        </p:txBody>
+      </p:sp>
+      <p:sp>
+        <p:nvSpPr>
+          <p:cNvPr id="15" name="TextBox 14"/>
           <p:cNvSpPr txBox="1"/>
           <p:nvPr/>
         </p:nvSpPr>
         <p:spPr>
           <a:xfrm>
-            <a:off x="640080" y="1280160"/>
-            <a:ext cx="10972800" cy="5212080"/>
+            <a:off x="640080" y="6400800"/>
+            <a:ext cx="8686800" cy="320040"/>
           </a:xfrm>
           <a:prstGeom prst="rect">
             <a:avLst/>
@@ -3643,101 +4064,29 @@
           </a:bodyPr>
           <a:lstStyle/>
           <a:p>
-            <a:pPr algn="r" rtl="1">
-              <a:spcBef>
-                <a:spcPts val="200"/>
-              </a:spcBef>
-              <a:spcAft>
-                <a:spcPts val="1000"/>
-              </a:spcAft>
-            </a:pPr>
-            <a:r>
-              <a:rPr sz="2000">
-                <a:solidFill>
-                  <a:srgbClr val="333333"/>
+            <a:pPr algn="r" rtl="1"/>
+            <a:r>
+              <a:rPr sz="1000" b="0">
+                <a:solidFill>
+                  <a:srgbClr val="666666"/>
                 </a:solidFill>
                 <a:latin typeface="Arial"/>
-                <a:cs typeface="Arial"/>
-                <a:ea typeface="Calibri"/>
-              </a:rPr>
-              <a:t>• توثيق Feast.</a:t>
-            </a:r>
-          </a:p>
-          <a:p>
-            <a:pPr algn="r" rtl="0">
-              <a:spcBef>
-                <a:spcPts val="200"/>
-              </a:spcBef>
-              <a:spcAft>
-                <a:spcPts val="1000"/>
-              </a:spcAft>
-            </a:pPr>
-            <a:r>
-              <a:rPr sz="1700">
-                <a:solidFill>
-                  <a:srgbClr val="666666"/>
-                </a:solidFill>
-                <a:latin typeface="Calibri"/>
-                <a:cs typeface="Arial"/>
-                <a:ea typeface="Calibri"/>
-              </a:rPr>
-              <a:t>• Feast documentation.</a:t>
-            </a:r>
-          </a:p>
-          <a:p>
-            <a:pPr algn="r" rtl="1">
-              <a:spcBef>
-                <a:spcPts val="200"/>
-              </a:spcBef>
-              <a:spcAft>
-                <a:spcPts val="1000"/>
-              </a:spcAft>
-            </a:pPr>
-            <a:r>
-              <a:rPr sz="2000">
-                <a:solidFill>
-                  <a:srgbClr val="333333"/>
-                </a:solidFill>
-                <a:latin typeface="Arial"/>
-                <a:cs typeface="Arial"/>
-                <a:ea typeface="Calibri"/>
-              </a:rPr>
-              <a:t>• توثيق Hopsworks Feature Store.</a:t>
-            </a:r>
-          </a:p>
-          <a:p>
-            <a:pPr algn="r" rtl="0">
-              <a:spcBef>
-                <a:spcPts val="200"/>
-              </a:spcBef>
-              <a:spcAft>
-                <a:spcPts val="1000"/>
-              </a:spcAft>
-            </a:pPr>
-            <a:r>
-              <a:rPr sz="1700">
-                <a:solidFill>
-                  <a:srgbClr val="666666"/>
-                </a:solidFill>
-                <a:latin typeface="Calibri"/>
-                <a:cs typeface="Arial"/>
-                <a:ea typeface="Calibri"/>
-              </a:rPr>
-              <a:t>• Hopsworks feature store docs.</a:t>
-            </a:r>
-          </a:p>
-        </p:txBody>
-      </p:sp>
-      <p:sp>
-        <p:nvSpPr>
-          <p:cNvPr id="5" name="TextBox 4"/>
+              </a:rPr>
+              <a:t>Module 02 — Data &amp; AI Engineering Track  |  الوحدة الثانية</a:t>
+            </a:r>
+          </a:p>
+        </p:txBody>
+      </p:sp>
+      <p:sp>
+        <p:nvSpPr>
+          <p:cNvPr id="16" name="TextBox 15"/>
           <p:cNvSpPr txBox="1"/>
           <p:nvPr/>
         </p:nvSpPr>
         <p:spPr>
           <a:xfrm>
-            <a:off x="640080" y="6400800"/>
-            <a:ext cx="8686800" cy="320040"/>
+            <a:off x="9601200" y="6400800"/>
+            <a:ext cx="1920240" cy="320040"/>
           </a:xfrm>
           <a:prstGeom prst="rect">
             <a:avLst/>
@@ -3750,202 +4099,15 @@
           </a:bodyPr>
           <a:lstStyle/>
           <a:p>
-            <a:pPr algn="r" rtl="1"/>
+            <a:pPr algn="l" rtl="0"/>
             <a:r>
               <a:rPr sz="1000" b="0">
                 <a:solidFill>
                   <a:srgbClr val="666666"/>
                 </a:solidFill>
-                <a:latin typeface="Arial"/>
-                <a:cs typeface="Arial"/>
-                <a:ea typeface="Calibri"/>
-              </a:rPr>
-              <a:t>Module 02 — Data &amp; AI Engineering Track  |  الوحدة الثانية</a:t>
-            </a:r>
-          </a:p>
-        </p:txBody>
-      </p:sp>
-      <p:sp>
-        <p:nvSpPr>
-          <p:cNvPr id="6" name="TextBox 5"/>
-          <p:cNvSpPr txBox="1"/>
-          <p:nvPr/>
-        </p:nvSpPr>
-        <p:spPr>
-          <a:xfrm>
-            <a:off x="9601200" y="6400800"/>
-            <a:ext cx="1920240" cy="320040"/>
-          </a:xfrm>
-          <a:prstGeom prst="rect">
-            <a:avLst/>
-          </a:prstGeom>
-          <a:noFill/>
-        </p:spPr>
-        <p:txBody>
-          <a:bodyPr wrap="square">
-            <a:spAutoFit/>
-          </a:bodyPr>
-          <a:lstStyle/>
-          <a:p>
-            <a:pPr algn="l" rtl="0"/>
-            <a:r>
-              <a:rPr sz="1000" b="0">
-                <a:solidFill>
-                  <a:srgbClr val="666666"/>
-                </a:solidFill>
                 <a:latin typeface="Calibri"/>
-                <a:cs typeface="Arial"/>
-                <a:ea typeface="Calibri"/>
-              </a:rPr>
-              <a:t>V08  •  9/12</a:t>
-            </a:r>
-          </a:p>
-        </p:txBody>
-      </p:sp>
-      <p:sp>
-        <p:nvSpPr>
-          <p:cNvPr id="7" name="TextBox 6"/>
-          <p:cNvSpPr txBox="1"/>
-          <p:nvPr/>
-        </p:nvSpPr>
-        <p:spPr>
-          <a:xfrm>
-            <a:off x="640080" y="6400800"/>
-            <a:ext cx="8686800" cy="320040"/>
-          </a:xfrm>
-          <a:prstGeom prst="rect">
-            <a:avLst/>
-          </a:prstGeom>
-          <a:noFill/>
-        </p:spPr>
-        <p:txBody>
-          <a:bodyPr wrap="square">
-            <a:spAutoFit/>
-          </a:bodyPr>
-          <a:lstStyle/>
-          <a:p>
-            <a:pPr algn="r" rtl="1"/>
-            <a:r>
-              <a:rPr sz="1000" b="0">
-                <a:solidFill>
-                  <a:srgbClr val="666666"/>
-                </a:solidFill>
-                <a:latin typeface="Arial"/>
-                <a:cs typeface="Arial"/>
-                <a:ea typeface="Calibri"/>
-              </a:rPr>
-              <a:t>Module 02 — Data &amp; AI Engineering Track  |  الوحدة الثانية</a:t>
-            </a:r>
-          </a:p>
-        </p:txBody>
-      </p:sp>
-      <p:sp>
-        <p:nvSpPr>
-          <p:cNvPr id="8" name="TextBox 7"/>
-          <p:cNvSpPr txBox="1"/>
-          <p:nvPr/>
-        </p:nvSpPr>
-        <p:spPr>
-          <a:xfrm>
-            <a:off x="9601200" y="6400800"/>
-            <a:ext cx="1920240" cy="320040"/>
-          </a:xfrm>
-          <a:prstGeom prst="rect">
-            <a:avLst/>
-          </a:prstGeom>
-          <a:noFill/>
-        </p:spPr>
-        <p:txBody>
-          <a:bodyPr wrap="square">
-            <a:spAutoFit/>
-          </a:bodyPr>
-          <a:lstStyle/>
-          <a:p>
-            <a:pPr algn="l" rtl="0"/>
-            <a:r>
-              <a:rPr sz="1000" b="0">
-                <a:solidFill>
-                  <a:srgbClr val="666666"/>
-                </a:solidFill>
-                <a:latin typeface="Calibri"/>
-                <a:cs typeface="Arial"/>
-                <a:ea typeface="Calibri"/>
-              </a:rPr>
-              <a:t>08_  •  10/10</a:t>
-            </a:r>
-          </a:p>
-        </p:txBody>
-      </p:sp>
-      <p:sp>
-        <p:nvSpPr>
-          <p:cNvPr id="9" name="TextBox 8"/>
-          <p:cNvSpPr txBox="1"/>
-          <p:nvPr/>
-        </p:nvSpPr>
-        <p:spPr>
-          <a:xfrm>
-            <a:off x="640080" y="6400800"/>
-            <a:ext cx="8686800" cy="320040"/>
-          </a:xfrm>
-          <a:prstGeom prst="rect">
-            <a:avLst/>
-          </a:prstGeom>
-          <a:noFill/>
-        </p:spPr>
-        <p:txBody>
-          <a:bodyPr wrap="square">
-            <a:spAutoFit/>
-          </a:bodyPr>
-          <a:lstStyle/>
-          <a:p>
-            <a:pPr algn="r" rtl="1"/>
-            <a:r>
-              <a:rPr sz="1000" b="0">
-                <a:solidFill>
-                  <a:srgbClr val="666666"/>
-                </a:solidFill>
-                <a:latin typeface="Arial"/>
-                <a:cs typeface="Arial"/>
-                <a:ea typeface="Calibri"/>
-              </a:rPr>
-              <a:t>Module 02 — Data &amp; AI Engineering Track  |  الوحدة الثانية</a:t>
-            </a:r>
-          </a:p>
-        </p:txBody>
-      </p:sp>
-      <p:sp>
-        <p:nvSpPr>
-          <p:cNvPr id="10" name="TextBox 9"/>
-          <p:cNvSpPr txBox="1"/>
-          <p:nvPr/>
-        </p:nvSpPr>
-        <p:spPr>
-          <a:xfrm>
-            <a:off x="9601200" y="6400800"/>
-            <a:ext cx="1920240" cy="320040"/>
-          </a:xfrm>
-          <a:prstGeom prst="rect">
-            <a:avLst/>
-          </a:prstGeom>
-          <a:noFill/>
-        </p:spPr>
-        <p:txBody>
-          <a:bodyPr wrap="square">
-            <a:spAutoFit/>
-          </a:bodyPr>
-          <a:lstStyle/>
-          <a:p>
-            <a:pPr algn="l" rtl="0"/>
-            <a:r>
-              <a:rPr sz="1000" b="0">
-                <a:solidFill>
-                  <a:srgbClr val="666666"/>
-                </a:solidFill>
-                <a:latin typeface="Calibri"/>
-                <a:cs typeface="Arial"/>
-                <a:ea typeface="Calibri"/>
-              </a:rPr>
-              <a:t>08_  •  10/10</a:t>
+              </a:rPr>
+              <a:t>V08  •  6/10</a:t>
             </a:r>
           </a:p>
         </p:txBody>
@@ -4051,8 +4213,6 @@
                   <a:srgbClr val="1F3B5C"/>
                 </a:solidFill>
                 <a:latin typeface="Arial"/>
-                <a:cs typeface="Arial"/>
-                <a:ea typeface="Calibri"/>
               </a:rPr>
               <a:t>أجندة العرض / Agenda</a:t>
             </a:r>
@@ -4095,14 +4255,12 @@
                   <a:srgbClr val="333333"/>
                 </a:solidFill>
                 <a:latin typeface="Arial"/>
-                <a:cs typeface="Arial"/>
-                <a:ea typeface="Calibri"/>
               </a:rPr>
               <a:t>• V08 — هندسة الخصائص ومخازنها</a:t>
             </a:r>
           </a:p>
           <a:p>
-            <a:pPr algn="r" rtl="0">
+            <a:pPr algn="l" rtl="0">
               <a:spcBef>
                 <a:spcPts val="200"/>
               </a:spcBef>
@@ -4116,8 +4274,6 @@
                   <a:srgbClr val="666666"/>
                 </a:solidFill>
                 <a:latin typeface="Calibri"/>
-                <a:cs typeface="Arial"/>
-                <a:ea typeface="Calibri"/>
               </a:rPr>
               <a:t>• V08 — Feature Engineering &amp; Feature Stores</a:t>
             </a:r>
@@ -4137,8 +4293,6 @@
                   <a:srgbClr val="333333"/>
                 </a:solidFill>
                 <a:latin typeface="Arial"/>
-                <a:cs typeface="Arial"/>
-                <a:ea typeface="Calibri"/>
               </a:rPr>
               <a:t>• هندسة الخصائص / Feature Engineering</a:t>
             </a:r>
@@ -4158,8 +4312,6 @@
                   <a:srgbClr val="333333"/>
                 </a:solidFill>
                 <a:latin typeface="Arial"/>
-                <a:cs typeface="Arial"/>
-                <a:ea typeface="Calibri"/>
               </a:rPr>
               <a:t>• مخازن الخصائص / Feature Stores</a:t>
             </a:r>
@@ -4179,8 +4331,6 @@
                   <a:srgbClr val="333333"/>
                 </a:solidFill>
                 <a:latin typeface="Arial"/>
-                <a:cs typeface="Arial"/>
-                <a:ea typeface="Calibri"/>
               </a:rPr>
               <a:t>• اتساق Offline/Online / Consistency</a:t>
             </a:r>
@@ -4200,8 +4350,6 @@
                   <a:srgbClr val="333333"/>
                 </a:solidFill>
                 <a:latin typeface="Arial"/>
-                <a:cs typeface="Arial"/>
-                <a:ea typeface="Calibri"/>
               </a:rPr>
               <a:t>• الربط بالتطبيقات الوكيلة / Agentic Applications</a:t>
             </a:r>
@@ -4237,8 +4385,6 @@
                   <a:srgbClr val="666666"/>
                 </a:solidFill>
                 <a:latin typeface="Arial"/>
-                <a:cs typeface="Arial"/>
-                <a:ea typeface="Calibri"/>
               </a:rPr>
               <a:t>Module 02 — Data &amp; AI Engineering Track  |  الوحدة الثانية</a:t>
             </a:r>
@@ -4274,158 +4420,8 @@
                   <a:srgbClr val="666666"/>
                 </a:solidFill>
                 <a:latin typeface="Calibri"/>
-                <a:cs typeface="Arial"/>
-                <a:ea typeface="Calibri"/>
-              </a:rPr>
-              <a:t>V08  •  2/12</a:t>
-            </a:r>
-          </a:p>
-        </p:txBody>
-      </p:sp>
-      <p:sp>
-        <p:nvSpPr>
-          <p:cNvPr id="7" name="TextBox 6"/>
-          <p:cNvSpPr txBox="1"/>
-          <p:nvPr/>
-        </p:nvSpPr>
-        <p:spPr>
-          <a:xfrm>
-            <a:off x="640080" y="6400800"/>
-            <a:ext cx="8686800" cy="320040"/>
-          </a:xfrm>
-          <a:prstGeom prst="rect">
-            <a:avLst/>
-          </a:prstGeom>
-          <a:noFill/>
-        </p:spPr>
-        <p:txBody>
-          <a:bodyPr wrap="square">
-            <a:spAutoFit/>
-          </a:bodyPr>
-          <a:lstStyle/>
-          <a:p>
-            <a:pPr algn="r" rtl="1"/>
-            <a:r>
-              <a:rPr sz="1000" b="0">
-                <a:solidFill>
-                  <a:srgbClr val="666666"/>
-                </a:solidFill>
-                <a:latin typeface="Arial"/>
-                <a:cs typeface="Arial"/>
-                <a:ea typeface="Calibri"/>
-              </a:rPr>
-              <a:t>Module 02 — Data &amp; AI Engineering Track  |  الوحدة الثانية</a:t>
-            </a:r>
-          </a:p>
-        </p:txBody>
-      </p:sp>
-      <p:sp>
-        <p:nvSpPr>
-          <p:cNvPr id="8" name="TextBox 7"/>
-          <p:cNvSpPr txBox="1"/>
-          <p:nvPr/>
-        </p:nvSpPr>
-        <p:spPr>
-          <a:xfrm>
-            <a:off x="9601200" y="6400800"/>
-            <a:ext cx="1920240" cy="320040"/>
-          </a:xfrm>
-          <a:prstGeom prst="rect">
-            <a:avLst/>
-          </a:prstGeom>
-          <a:noFill/>
-        </p:spPr>
-        <p:txBody>
-          <a:bodyPr wrap="square">
-            <a:spAutoFit/>
-          </a:bodyPr>
-          <a:lstStyle/>
-          <a:p>
-            <a:pPr algn="l" rtl="0"/>
-            <a:r>
-              <a:rPr sz="1000" b="0">
-                <a:solidFill>
-                  <a:srgbClr val="666666"/>
-                </a:solidFill>
-                <a:latin typeface="Calibri"/>
-                <a:cs typeface="Arial"/>
-                <a:ea typeface="Calibri"/>
-              </a:rPr>
-              <a:t>08_  •  2/10</a:t>
-            </a:r>
-          </a:p>
-        </p:txBody>
-      </p:sp>
-      <p:sp>
-        <p:nvSpPr>
-          <p:cNvPr id="9" name="TextBox 8"/>
-          <p:cNvSpPr txBox="1"/>
-          <p:nvPr/>
-        </p:nvSpPr>
-        <p:spPr>
-          <a:xfrm>
-            <a:off x="640080" y="6400800"/>
-            <a:ext cx="8686800" cy="320040"/>
-          </a:xfrm>
-          <a:prstGeom prst="rect">
-            <a:avLst/>
-          </a:prstGeom>
-          <a:noFill/>
-        </p:spPr>
-        <p:txBody>
-          <a:bodyPr wrap="square">
-            <a:spAutoFit/>
-          </a:bodyPr>
-          <a:lstStyle/>
-          <a:p>
-            <a:pPr algn="r" rtl="1"/>
-            <a:r>
-              <a:rPr sz="1000" b="0">
-                <a:solidFill>
-                  <a:srgbClr val="666666"/>
-                </a:solidFill>
-                <a:latin typeface="Arial"/>
-                <a:cs typeface="Arial"/>
-                <a:ea typeface="Calibri"/>
-              </a:rPr>
-              <a:t>Module 02 — Data &amp; AI Engineering Track  |  الوحدة الثانية</a:t>
-            </a:r>
-          </a:p>
-        </p:txBody>
-      </p:sp>
-      <p:sp>
-        <p:nvSpPr>
-          <p:cNvPr id="10" name="TextBox 9"/>
-          <p:cNvSpPr txBox="1"/>
-          <p:nvPr/>
-        </p:nvSpPr>
-        <p:spPr>
-          <a:xfrm>
-            <a:off x="9601200" y="6400800"/>
-            <a:ext cx="1920240" cy="320040"/>
-          </a:xfrm>
-          <a:prstGeom prst="rect">
-            <a:avLst/>
-          </a:prstGeom>
-          <a:noFill/>
-        </p:spPr>
-        <p:txBody>
-          <a:bodyPr wrap="square">
-            <a:spAutoFit/>
-          </a:bodyPr>
-          <a:lstStyle/>
-          <a:p>
-            <a:pPr algn="l" rtl="0"/>
-            <a:r>
-              <a:rPr sz="1000" b="0">
-                <a:solidFill>
-                  <a:srgbClr val="666666"/>
-                </a:solidFill>
-                <a:latin typeface="Calibri"/>
-                <a:cs typeface="Arial"/>
-                <a:ea typeface="Calibri"/>
-              </a:rPr>
-              <a:t>08_  •  2/10</a:t>
+              </a:rPr>
+              <a:t>V08  •  2/10</a:t>
             </a:r>
           </a:p>
         </p:txBody>
@@ -4531,8 +4527,6 @@
                   <a:srgbClr val="1F3B5C"/>
                 </a:solidFill>
                 <a:latin typeface="Arial"/>
-                <a:cs typeface="Arial"/>
-                <a:ea typeface="Calibri"/>
               </a:rPr>
               <a:t>هندسة الخصائص / Feature Engineering</a:t>
             </a:r>
@@ -4575,14 +4569,12 @@
                   <a:srgbClr val="333333"/>
                 </a:solidFill>
                 <a:latin typeface="Arial"/>
-                <a:cs typeface="Arial"/>
-                <a:ea typeface="Calibri"/>
               </a:rPr>
               <a:t>• تحويل البيانات الخام إلى ميزات ذات معنى تدعم تدريب النماذج وخدمتها.</a:t>
             </a:r>
           </a:p>
           <a:p>
-            <a:pPr algn="r" rtl="0">
+            <a:pPr algn="l" rtl="0">
               <a:spcBef>
                 <a:spcPts val="200"/>
               </a:spcBef>
@@ -4596,8 +4588,6 @@
                   <a:srgbClr val="666666"/>
                 </a:solidFill>
                 <a:latin typeface="Calibri"/>
-                <a:cs typeface="Arial"/>
-                <a:ea typeface="Calibri"/>
               </a:rPr>
               <a:t>• Turning raw data into meaningful features supporting model training and serving.</a:t>
             </a:r>
@@ -4617,14 +4607,12 @@
                   <a:srgbClr val="333333"/>
                 </a:solidFill>
                 <a:latin typeface="Arial"/>
-                <a:cs typeface="Arial"/>
-                <a:ea typeface="Calibri"/>
               </a:rPr>
               <a:t>• أمثلة: التجميعات الزمنية، الترميز، التطبيع.</a:t>
             </a:r>
           </a:p>
           <a:p>
-            <a:pPr algn="r" rtl="0">
+            <a:pPr algn="l" rtl="0">
               <a:spcBef>
                 <a:spcPts val="200"/>
               </a:spcBef>
@@ -4638,8 +4626,6 @@
                   <a:srgbClr val="666666"/>
                 </a:solidFill>
                 <a:latin typeface="Calibri"/>
-                <a:cs typeface="Arial"/>
-                <a:ea typeface="Calibri"/>
               </a:rPr>
               <a:t>• Examples: time-window aggregates, encoding, normalization.</a:t>
             </a:r>
@@ -4675,8 +4661,6 @@
                   <a:srgbClr val="666666"/>
                 </a:solidFill>
                 <a:latin typeface="Arial"/>
-                <a:cs typeface="Arial"/>
-                <a:ea typeface="Calibri"/>
               </a:rPr>
               <a:t>Module 02 — Data &amp; AI Engineering Track  |  الوحدة الثانية</a:t>
             </a:r>
@@ -4712,158 +4696,8 @@
                   <a:srgbClr val="666666"/>
                 </a:solidFill>
                 <a:latin typeface="Calibri"/>
-                <a:cs typeface="Arial"/>
-                <a:ea typeface="Calibri"/>
-              </a:rPr>
-              <a:t>V08  •  3/12</a:t>
-            </a:r>
-          </a:p>
-        </p:txBody>
-      </p:sp>
-      <p:sp>
-        <p:nvSpPr>
-          <p:cNvPr id="7" name="TextBox 6"/>
-          <p:cNvSpPr txBox="1"/>
-          <p:nvPr/>
-        </p:nvSpPr>
-        <p:spPr>
-          <a:xfrm>
-            <a:off x="640080" y="6400800"/>
-            <a:ext cx="8686800" cy="320040"/>
-          </a:xfrm>
-          <a:prstGeom prst="rect">
-            <a:avLst/>
-          </a:prstGeom>
-          <a:noFill/>
-        </p:spPr>
-        <p:txBody>
-          <a:bodyPr wrap="square">
-            <a:spAutoFit/>
-          </a:bodyPr>
-          <a:lstStyle/>
-          <a:p>
-            <a:pPr algn="r" rtl="1"/>
-            <a:r>
-              <a:rPr sz="1000" b="0">
-                <a:solidFill>
-                  <a:srgbClr val="666666"/>
-                </a:solidFill>
-                <a:latin typeface="Arial"/>
-                <a:cs typeface="Arial"/>
-                <a:ea typeface="Calibri"/>
-              </a:rPr>
-              <a:t>Module 02 — Data &amp; AI Engineering Track  |  الوحدة الثانية</a:t>
-            </a:r>
-          </a:p>
-        </p:txBody>
-      </p:sp>
-      <p:sp>
-        <p:nvSpPr>
-          <p:cNvPr id="8" name="TextBox 7"/>
-          <p:cNvSpPr txBox="1"/>
-          <p:nvPr/>
-        </p:nvSpPr>
-        <p:spPr>
-          <a:xfrm>
-            <a:off x="9601200" y="6400800"/>
-            <a:ext cx="1920240" cy="320040"/>
-          </a:xfrm>
-          <a:prstGeom prst="rect">
-            <a:avLst/>
-          </a:prstGeom>
-          <a:noFill/>
-        </p:spPr>
-        <p:txBody>
-          <a:bodyPr wrap="square">
-            <a:spAutoFit/>
-          </a:bodyPr>
-          <a:lstStyle/>
-          <a:p>
-            <a:pPr algn="l" rtl="0"/>
-            <a:r>
-              <a:rPr sz="1000" b="0">
-                <a:solidFill>
-                  <a:srgbClr val="666666"/>
-                </a:solidFill>
-                <a:latin typeface="Calibri"/>
-                <a:cs typeface="Arial"/>
-                <a:ea typeface="Calibri"/>
-              </a:rPr>
-              <a:t>08_  •  3/10</a:t>
-            </a:r>
-          </a:p>
-        </p:txBody>
-      </p:sp>
-      <p:sp>
-        <p:nvSpPr>
-          <p:cNvPr id="9" name="TextBox 8"/>
-          <p:cNvSpPr txBox="1"/>
-          <p:nvPr/>
-        </p:nvSpPr>
-        <p:spPr>
-          <a:xfrm>
-            <a:off x="640080" y="6400800"/>
-            <a:ext cx="8686800" cy="320040"/>
-          </a:xfrm>
-          <a:prstGeom prst="rect">
-            <a:avLst/>
-          </a:prstGeom>
-          <a:noFill/>
-        </p:spPr>
-        <p:txBody>
-          <a:bodyPr wrap="square">
-            <a:spAutoFit/>
-          </a:bodyPr>
-          <a:lstStyle/>
-          <a:p>
-            <a:pPr algn="r" rtl="1"/>
-            <a:r>
-              <a:rPr sz="1000" b="0">
-                <a:solidFill>
-                  <a:srgbClr val="666666"/>
-                </a:solidFill>
-                <a:latin typeface="Arial"/>
-                <a:cs typeface="Arial"/>
-                <a:ea typeface="Calibri"/>
-              </a:rPr>
-              <a:t>Module 02 — Data &amp; AI Engineering Track  |  الوحدة الثانية</a:t>
-            </a:r>
-          </a:p>
-        </p:txBody>
-      </p:sp>
-      <p:sp>
-        <p:nvSpPr>
-          <p:cNvPr id="10" name="TextBox 9"/>
-          <p:cNvSpPr txBox="1"/>
-          <p:nvPr/>
-        </p:nvSpPr>
-        <p:spPr>
-          <a:xfrm>
-            <a:off x="9601200" y="6400800"/>
-            <a:ext cx="1920240" cy="320040"/>
-          </a:xfrm>
-          <a:prstGeom prst="rect">
-            <a:avLst/>
-          </a:prstGeom>
-          <a:noFill/>
-        </p:spPr>
-        <p:txBody>
-          <a:bodyPr wrap="square">
-            <a:spAutoFit/>
-          </a:bodyPr>
-          <a:lstStyle/>
-          <a:p>
-            <a:pPr algn="l" rtl="0"/>
-            <a:r>
-              <a:rPr sz="1000" b="0">
-                <a:solidFill>
-                  <a:srgbClr val="666666"/>
-                </a:solidFill>
-                <a:latin typeface="Calibri"/>
-                <a:cs typeface="Arial"/>
-                <a:ea typeface="Calibri"/>
-              </a:rPr>
-              <a:t>08_  •  3/10</a:t>
+              </a:rPr>
+              <a:t>V08  •  3/10</a:t>
             </a:r>
           </a:p>
         </p:txBody>
@@ -4969,8 +4803,6 @@
                   <a:srgbClr val="1F3B5C"/>
                 </a:solidFill>
                 <a:latin typeface="Arial"/>
-                <a:cs typeface="Arial"/>
-                <a:ea typeface="Calibri"/>
               </a:rPr>
               <a:t>مخازن الخصائص / Feature Stores</a:t>
             </a:r>
@@ -5013,14 +4845,12 @@
                   <a:srgbClr val="333333"/>
                 </a:solidFill>
                 <a:latin typeface="Arial"/>
-                <a:cs typeface="Arial"/>
-                <a:ea typeface="Calibri"/>
               </a:rPr>
               <a:t>• Feast وTecton وHopsworks: تعريف الميزة مرة واحدة وإعادة استخدامها في التدريب والخدمة.</a:t>
             </a:r>
           </a:p>
           <a:p>
-            <a:pPr algn="r" rtl="0">
+            <a:pPr algn="l" rtl="0">
               <a:spcBef>
                 <a:spcPts val="200"/>
               </a:spcBef>
@@ -5034,8 +4864,6 @@
                   <a:srgbClr val="666666"/>
                 </a:solidFill>
                 <a:latin typeface="Calibri"/>
-                <a:cs typeface="Arial"/>
-                <a:ea typeface="Calibri"/>
               </a:rPr>
               <a:t>• Feast, Tecton, Hopsworks: define features once, reuse for training and serving.</a:t>
             </a:r>
@@ -5055,14 +4883,12 @@
                   <a:srgbClr val="333333"/>
                 </a:solidFill>
                 <a:latin typeface="Arial"/>
-                <a:cs typeface="Arial"/>
-                <a:ea typeface="Calibri"/>
               </a:rPr>
               <a:t>• تمنع انحراف الميزات بين التدريب والإنتاج.</a:t>
             </a:r>
           </a:p>
           <a:p>
-            <a:pPr algn="r" rtl="0">
+            <a:pPr algn="l" rtl="0">
               <a:spcBef>
                 <a:spcPts val="200"/>
               </a:spcBef>
@@ -5076,8 +4902,6 @@
                   <a:srgbClr val="666666"/>
                 </a:solidFill>
                 <a:latin typeface="Calibri"/>
-                <a:cs typeface="Arial"/>
-                <a:ea typeface="Calibri"/>
               </a:rPr>
               <a:t>• They prevent feature skew between training and production.</a:t>
             </a:r>
@@ -5113,8 +4937,6 @@
                   <a:srgbClr val="666666"/>
                 </a:solidFill>
                 <a:latin typeface="Arial"/>
-                <a:cs typeface="Arial"/>
-                <a:ea typeface="Calibri"/>
               </a:rPr>
               <a:t>Module 02 — Data &amp; AI Engineering Track  |  الوحدة الثانية</a:t>
             </a:r>
@@ -5150,158 +4972,8 @@
                   <a:srgbClr val="666666"/>
                 </a:solidFill>
                 <a:latin typeface="Calibri"/>
-                <a:cs typeface="Arial"/>
-                <a:ea typeface="Calibri"/>
-              </a:rPr>
-              <a:t>V08  •  4/12</a:t>
-            </a:r>
-          </a:p>
-        </p:txBody>
-      </p:sp>
-      <p:sp>
-        <p:nvSpPr>
-          <p:cNvPr id="7" name="TextBox 6"/>
-          <p:cNvSpPr txBox="1"/>
-          <p:nvPr/>
-        </p:nvSpPr>
-        <p:spPr>
-          <a:xfrm>
-            <a:off x="640080" y="6400800"/>
-            <a:ext cx="8686800" cy="320040"/>
-          </a:xfrm>
-          <a:prstGeom prst="rect">
-            <a:avLst/>
-          </a:prstGeom>
-          <a:noFill/>
-        </p:spPr>
-        <p:txBody>
-          <a:bodyPr wrap="square">
-            <a:spAutoFit/>
-          </a:bodyPr>
-          <a:lstStyle/>
-          <a:p>
-            <a:pPr algn="r" rtl="1"/>
-            <a:r>
-              <a:rPr sz="1000" b="0">
-                <a:solidFill>
-                  <a:srgbClr val="666666"/>
-                </a:solidFill>
-                <a:latin typeface="Arial"/>
-                <a:cs typeface="Arial"/>
-                <a:ea typeface="Calibri"/>
-              </a:rPr>
-              <a:t>Module 02 — Data &amp; AI Engineering Track  |  الوحدة الثانية</a:t>
-            </a:r>
-          </a:p>
-        </p:txBody>
-      </p:sp>
-      <p:sp>
-        <p:nvSpPr>
-          <p:cNvPr id="8" name="TextBox 7"/>
-          <p:cNvSpPr txBox="1"/>
-          <p:nvPr/>
-        </p:nvSpPr>
-        <p:spPr>
-          <a:xfrm>
-            <a:off x="9601200" y="6400800"/>
-            <a:ext cx="1920240" cy="320040"/>
-          </a:xfrm>
-          <a:prstGeom prst="rect">
-            <a:avLst/>
-          </a:prstGeom>
-          <a:noFill/>
-        </p:spPr>
-        <p:txBody>
-          <a:bodyPr wrap="square">
-            <a:spAutoFit/>
-          </a:bodyPr>
-          <a:lstStyle/>
-          <a:p>
-            <a:pPr algn="l" rtl="0"/>
-            <a:r>
-              <a:rPr sz="1000" b="0">
-                <a:solidFill>
-                  <a:srgbClr val="666666"/>
-                </a:solidFill>
-                <a:latin typeface="Calibri"/>
-                <a:cs typeface="Arial"/>
-                <a:ea typeface="Calibri"/>
-              </a:rPr>
-              <a:t>08_  •  4/10</a:t>
-            </a:r>
-          </a:p>
-        </p:txBody>
-      </p:sp>
-      <p:sp>
-        <p:nvSpPr>
-          <p:cNvPr id="9" name="TextBox 8"/>
-          <p:cNvSpPr txBox="1"/>
-          <p:nvPr/>
-        </p:nvSpPr>
-        <p:spPr>
-          <a:xfrm>
-            <a:off x="640080" y="6400800"/>
-            <a:ext cx="8686800" cy="320040"/>
-          </a:xfrm>
-          <a:prstGeom prst="rect">
-            <a:avLst/>
-          </a:prstGeom>
-          <a:noFill/>
-        </p:spPr>
-        <p:txBody>
-          <a:bodyPr wrap="square">
-            <a:spAutoFit/>
-          </a:bodyPr>
-          <a:lstStyle/>
-          <a:p>
-            <a:pPr algn="r" rtl="1"/>
-            <a:r>
-              <a:rPr sz="1000" b="0">
-                <a:solidFill>
-                  <a:srgbClr val="666666"/>
-                </a:solidFill>
-                <a:latin typeface="Arial"/>
-                <a:cs typeface="Arial"/>
-                <a:ea typeface="Calibri"/>
-              </a:rPr>
-              <a:t>Module 02 — Data &amp; AI Engineering Track  |  الوحدة الثانية</a:t>
-            </a:r>
-          </a:p>
-        </p:txBody>
-      </p:sp>
-      <p:sp>
-        <p:nvSpPr>
-          <p:cNvPr id="10" name="TextBox 9"/>
-          <p:cNvSpPr txBox="1"/>
-          <p:nvPr/>
-        </p:nvSpPr>
-        <p:spPr>
-          <a:xfrm>
-            <a:off x="9601200" y="6400800"/>
-            <a:ext cx="1920240" cy="320040"/>
-          </a:xfrm>
-          <a:prstGeom prst="rect">
-            <a:avLst/>
-          </a:prstGeom>
-          <a:noFill/>
-        </p:spPr>
-        <p:txBody>
-          <a:bodyPr wrap="square">
-            <a:spAutoFit/>
-          </a:bodyPr>
-          <a:lstStyle/>
-          <a:p>
-            <a:pPr algn="l" rtl="0"/>
-            <a:r>
-              <a:rPr sz="1000" b="0">
-                <a:solidFill>
-                  <a:srgbClr val="666666"/>
-                </a:solidFill>
-                <a:latin typeface="Calibri"/>
-                <a:cs typeface="Arial"/>
-                <a:ea typeface="Calibri"/>
-              </a:rPr>
-              <a:t>08_  •  4/10</a:t>
+              </a:rPr>
+              <a:t>V08  •  4/10</a:t>
             </a:r>
           </a:p>
         </p:txBody>
@@ -5407,8 +5079,6 @@
                   <a:srgbClr val="1F3B5C"/>
                 </a:solidFill>
                 <a:latin typeface="Arial"/>
-                <a:cs typeface="Arial"/>
-                <a:ea typeface="Calibri"/>
               </a:rPr>
               <a:t>اتساق Offline/Online / Consistency</a:t>
             </a:r>
@@ -5451,14 +5121,12 @@
                   <a:srgbClr val="333333"/>
                 </a:solidFill>
                 <a:latin typeface="Arial"/>
-                <a:cs typeface="Arial"/>
-                <a:ea typeface="Calibri"/>
               </a:rPr>
               <a:t>• Offline للتدريب التاريخي؛ Online لخدمة منخفضة الكمون (ميلي ثانية).</a:t>
             </a:r>
           </a:p>
           <a:p>
-            <a:pPr algn="r" rtl="0">
+            <a:pPr algn="l" rtl="0">
               <a:spcBef>
                 <a:spcPts val="200"/>
               </a:spcBef>
@@ -5472,8 +5140,6 @@
                   <a:srgbClr val="666666"/>
                 </a:solidFill>
                 <a:latin typeface="Calibri"/>
-                <a:cs typeface="Arial"/>
-                <a:ea typeface="Calibri"/>
               </a:rPr>
               <a:t>• Offline for historical training; online for low-latency (ms) serving.</a:t>
             </a:r>
@@ -5493,14 +5159,12 @@
                   <a:srgbClr val="333333"/>
                 </a:solidFill>
                 <a:latin typeface="Arial"/>
-                <a:cs typeface="Arial"/>
-                <a:ea typeface="Calibri"/>
               </a:rPr>
               <a:t>• اتساق القيم بين البيئتين شرط لصحة النموذج في الإنتاج.</a:t>
             </a:r>
           </a:p>
           <a:p>
-            <a:pPr algn="r" rtl="0">
+            <a:pPr algn="l" rtl="0">
               <a:spcBef>
                 <a:spcPts val="200"/>
               </a:spcBef>
@@ -5514,8 +5178,6 @@
                   <a:srgbClr val="666666"/>
                 </a:solidFill>
                 <a:latin typeface="Calibri"/>
-                <a:cs typeface="Arial"/>
-                <a:ea typeface="Calibri"/>
               </a:rPr>
               <a:t>• Value consistency across stores is essential for production correctness.</a:t>
             </a:r>
@@ -5551,8 +5213,6 @@
                   <a:srgbClr val="666666"/>
                 </a:solidFill>
                 <a:latin typeface="Arial"/>
-                <a:cs typeface="Arial"/>
-                <a:ea typeface="Calibri"/>
               </a:rPr>
               <a:t>Module 02 — Data &amp; AI Engineering Track  |  الوحدة الثانية</a:t>
             </a:r>
@@ -5588,158 +5248,8 @@
                   <a:srgbClr val="666666"/>
                 </a:solidFill>
                 <a:latin typeface="Calibri"/>
-                <a:cs typeface="Arial"/>
-                <a:ea typeface="Calibri"/>
-              </a:rPr>
-              <a:t>V08  •  5/12</a:t>
-            </a:r>
-          </a:p>
-        </p:txBody>
-      </p:sp>
-      <p:sp>
-        <p:nvSpPr>
-          <p:cNvPr id="7" name="TextBox 6"/>
-          <p:cNvSpPr txBox="1"/>
-          <p:nvPr/>
-        </p:nvSpPr>
-        <p:spPr>
-          <a:xfrm>
-            <a:off x="640080" y="6400800"/>
-            <a:ext cx="8686800" cy="320040"/>
-          </a:xfrm>
-          <a:prstGeom prst="rect">
-            <a:avLst/>
-          </a:prstGeom>
-          <a:noFill/>
-        </p:spPr>
-        <p:txBody>
-          <a:bodyPr wrap="square">
-            <a:spAutoFit/>
-          </a:bodyPr>
-          <a:lstStyle/>
-          <a:p>
-            <a:pPr algn="r" rtl="1"/>
-            <a:r>
-              <a:rPr sz="1000" b="0">
-                <a:solidFill>
-                  <a:srgbClr val="666666"/>
-                </a:solidFill>
-                <a:latin typeface="Arial"/>
-                <a:cs typeface="Arial"/>
-                <a:ea typeface="Calibri"/>
-              </a:rPr>
-              <a:t>Module 02 — Data &amp; AI Engineering Track  |  الوحدة الثانية</a:t>
-            </a:r>
-          </a:p>
-        </p:txBody>
-      </p:sp>
-      <p:sp>
-        <p:nvSpPr>
-          <p:cNvPr id="8" name="TextBox 7"/>
-          <p:cNvSpPr txBox="1"/>
-          <p:nvPr/>
-        </p:nvSpPr>
-        <p:spPr>
-          <a:xfrm>
-            <a:off x="9601200" y="6400800"/>
-            <a:ext cx="1920240" cy="320040"/>
-          </a:xfrm>
-          <a:prstGeom prst="rect">
-            <a:avLst/>
-          </a:prstGeom>
-          <a:noFill/>
-        </p:spPr>
-        <p:txBody>
-          <a:bodyPr wrap="square">
-            <a:spAutoFit/>
-          </a:bodyPr>
-          <a:lstStyle/>
-          <a:p>
-            <a:pPr algn="l" rtl="0"/>
-            <a:r>
-              <a:rPr sz="1000" b="0">
-                <a:solidFill>
-                  <a:srgbClr val="666666"/>
-                </a:solidFill>
-                <a:latin typeface="Calibri"/>
-                <a:cs typeface="Arial"/>
-                <a:ea typeface="Calibri"/>
-              </a:rPr>
-              <a:t>08_  •  5/10</a:t>
-            </a:r>
-          </a:p>
-        </p:txBody>
-      </p:sp>
-      <p:sp>
-        <p:nvSpPr>
-          <p:cNvPr id="9" name="TextBox 8"/>
-          <p:cNvSpPr txBox="1"/>
-          <p:nvPr/>
-        </p:nvSpPr>
-        <p:spPr>
-          <a:xfrm>
-            <a:off x="640080" y="6400800"/>
-            <a:ext cx="8686800" cy="320040"/>
-          </a:xfrm>
-          <a:prstGeom prst="rect">
-            <a:avLst/>
-          </a:prstGeom>
-          <a:noFill/>
-        </p:spPr>
-        <p:txBody>
-          <a:bodyPr wrap="square">
-            <a:spAutoFit/>
-          </a:bodyPr>
-          <a:lstStyle/>
-          <a:p>
-            <a:pPr algn="r" rtl="1"/>
-            <a:r>
-              <a:rPr sz="1000" b="0">
-                <a:solidFill>
-                  <a:srgbClr val="666666"/>
-                </a:solidFill>
-                <a:latin typeface="Arial"/>
-                <a:cs typeface="Arial"/>
-                <a:ea typeface="Calibri"/>
-              </a:rPr>
-              <a:t>Module 02 — Data &amp; AI Engineering Track  |  الوحدة الثانية</a:t>
-            </a:r>
-          </a:p>
-        </p:txBody>
-      </p:sp>
-      <p:sp>
-        <p:nvSpPr>
-          <p:cNvPr id="10" name="TextBox 9"/>
-          <p:cNvSpPr txBox="1"/>
-          <p:nvPr/>
-        </p:nvSpPr>
-        <p:spPr>
-          <a:xfrm>
-            <a:off x="9601200" y="6400800"/>
-            <a:ext cx="1920240" cy="320040"/>
-          </a:xfrm>
-          <a:prstGeom prst="rect">
-            <a:avLst/>
-          </a:prstGeom>
-          <a:noFill/>
-        </p:spPr>
-        <p:txBody>
-          <a:bodyPr wrap="square">
-            <a:spAutoFit/>
-          </a:bodyPr>
-          <a:lstStyle/>
-          <a:p>
-            <a:pPr algn="l" rtl="0"/>
-            <a:r>
-              <a:rPr sz="1000" b="0">
-                <a:solidFill>
-                  <a:srgbClr val="666666"/>
-                </a:solidFill>
-                <a:latin typeface="Calibri"/>
-                <a:cs typeface="Arial"/>
-                <a:ea typeface="Calibri"/>
-              </a:rPr>
-              <a:t>08_  •  5/10</a:t>
+              </a:rPr>
+              <a:t>V08  •  5/10</a:t>
             </a:r>
           </a:p>
         </p:txBody>
@@ -5772,59 +5282,22 @@
       <p:grpSpPr/>
       <p:sp>
         <p:nvSpPr>
-          <p:cNvPr id="2" name="TextBox 1"/>
-          <p:cNvSpPr txBox="1"/>
+          <p:cNvPr id="2" name="Rectangle 1"/>
+          <p:cNvSpPr/>
           <p:nvPr/>
         </p:nvSpPr>
         <p:spPr>
           <a:xfrm>
-            <a:off x="640080" y="137160"/>
-            <a:ext cx="10972800" cy="640080"/>
+            <a:off x="0" y="0"/>
+            <a:ext cx="12191695" cy="1005840"/>
           </a:xfrm>
           <a:prstGeom prst="rect">
             <a:avLst/>
           </a:prstGeom>
-          <a:noFill/>
-        </p:spPr>
-        <p:txBody>
-          <a:bodyPr wrap="none">
-            <a:spAutoFit/>
-          </a:bodyPr>
-          <a:lstStyle/>
-          <a:p>
-            <a:pPr algn="r" rtl="1"/>
-            <a:r>
-              <a:rPr sz="3000" b="1">
-                <a:solidFill>
-                  <a:srgbClr val="1F3B5C"/>
-                </a:solidFill>
-                <a:latin typeface="Arial"/>
-                <a:cs typeface="Arial"/>
-                <a:ea typeface="Calibri"/>
-              </a:rPr>
-              <a:t>معمارية مخزن الخصائص / Feature Store Architecture</a:t>
-            </a:r>
-          </a:p>
-        </p:txBody>
-      </p:sp>
-      <p:sp>
-        <p:nvSpPr>
-          <p:cNvPr id="3" name="Rounded Rectangle 2"/>
-          <p:cNvSpPr/>
-          <p:nvPr/>
-        </p:nvSpPr>
-        <p:spPr>
-          <a:xfrm>
-            <a:off x="640080" y="2560320"/>
-            <a:ext cx="2011680" cy="1188720"/>
-          </a:xfrm>
-          <a:prstGeom prst="roundRect">
-            <a:avLst/>
-          </a:prstGeom>
           <a:solidFill>
-            <a:srgbClr val="EDEDED"/>
+            <a:srgbClr val="FFFFFF"/>
           </a:solidFill>
-          <a:ln w="12700">
+          <a:ln w="25400">
             <a:solidFill>
               <a:srgbClr val="1F4E79"/>
             </a:solidFill>
@@ -5846,75 +5319,6 @@
           </a:fontRef>
         </p:style>
         <p:txBody>
-          <a:bodyPr rtlCol="0" anchor="ctr" wrap="square"/>
-          <a:lstStyle/>
-          <a:p>
-            <a:pPr algn="ctr" rtl="1"/>
-            <a:r>
-              <a:rPr sz="1400" b="1">
-                <a:solidFill>
-                  <a:srgbClr val="333333"/>
-                </a:solidFill>
-                <a:latin typeface="Arial"/>
-                <a:cs typeface="Arial"/>
-                <a:ea typeface="Calibri"/>
-              </a:rPr>
-              <a:t>مصادر البيانات</a:t>
-            </a:r>
-          </a:p>
-          <a:p>
-            <a:pPr algn="ctr" rtl="0"/>
-            <a:r>
-              <a:rPr sz="1100">
-                <a:solidFill>
-                  <a:srgbClr val="666666"/>
-                </a:solidFill>
-                <a:latin typeface="Calibri"/>
-                <a:cs typeface="Arial"/>
-                <a:ea typeface="Calibri"/>
-              </a:rPr>
-              <a:t>Data Sources</a:t>
-            </a:r>
-          </a:p>
-        </p:txBody>
-      </p:sp>
-      <p:sp>
-        <p:nvSpPr>
-          <p:cNvPr id="4" name="Left Arrow 3"/>
-          <p:cNvSpPr/>
-          <p:nvPr/>
-        </p:nvSpPr>
-        <p:spPr>
-          <a:xfrm>
-            <a:off x="2724912" y="3017520"/>
-            <a:ext cx="411480" cy="274320"/>
-          </a:xfrm>
-          <a:prstGeom prst="leftArrow">
-            <a:avLst/>
-          </a:prstGeom>
-          <a:solidFill>
-            <a:srgbClr val="1F4E79"/>
-          </a:solidFill>
-          <a:ln>
-            <a:noFill/>
-          </a:ln>
-          <a:effectLst/>
-        </p:spPr>
-        <p:style>
-          <a:lnRef idx="1">
-            <a:schemeClr val="accent1"/>
-          </a:lnRef>
-          <a:fillRef idx="3">
-            <a:schemeClr val="accent1"/>
-          </a:fillRef>
-          <a:effectRef idx="2">
-            <a:schemeClr val="accent1"/>
-          </a:effectRef>
-          <a:fontRef idx="minor">
-            <a:schemeClr val="lt1"/>
-          </a:fontRef>
-        </p:style>
-        <p:txBody>
           <a:bodyPr rtlCol="0" anchor="ctr"/>
           <a:lstStyle/>
           <a:p>
@@ -5924,548 +5328,14 @@
       </p:sp>
       <p:sp>
         <p:nvSpPr>
-          <p:cNvPr id="5" name="Rounded Rectangle 4"/>
-          <p:cNvSpPr/>
-          <p:nvPr/>
-        </p:nvSpPr>
-        <p:spPr>
-          <a:xfrm>
-            <a:off x="3200400" y="2560320"/>
-            <a:ext cx="2194560" cy="1188720"/>
-          </a:xfrm>
-          <a:prstGeom prst="roundRect">
-            <a:avLst/>
-          </a:prstGeom>
-          <a:solidFill>
-            <a:srgbClr val="DCE6F1"/>
-          </a:solidFill>
-          <a:ln w="12700">
-            <a:solidFill>
-              <a:srgbClr val="1F4E79"/>
-            </a:solidFill>
-          </a:ln>
-          <a:effectLst/>
-        </p:spPr>
-        <p:style>
-          <a:lnRef idx="1">
-            <a:schemeClr val="accent1"/>
-          </a:lnRef>
-          <a:fillRef idx="3">
-            <a:schemeClr val="accent1"/>
-          </a:fillRef>
-          <a:effectRef idx="2">
-            <a:schemeClr val="accent1"/>
-          </a:effectRef>
-          <a:fontRef idx="minor">
-            <a:schemeClr val="lt1"/>
-          </a:fontRef>
-        </p:style>
-        <p:txBody>
-          <a:bodyPr rtlCol="0" anchor="ctr" wrap="square"/>
-          <a:lstStyle/>
-          <a:p>
-            <a:pPr algn="ctr" rtl="1"/>
-            <a:r>
-              <a:rPr sz="1400" b="1">
-                <a:solidFill>
-                  <a:srgbClr val="333333"/>
-                </a:solidFill>
-                <a:latin typeface="Arial"/>
-                <a:cs typeface="Arial"/>
-                <a:ea typeface="Calibri"/>
-              </a:rPr>
-              <a:t>خط الخصائص</a:t>
-            </a:r>
-          </a:p>
-          <a:p>
-            <a:pPr algn="ctr" rtl="1"/>
-            <a:r>
-              <a:rPr sz="1100">
-                <a:solidFill>
-                  <a:srgbClr val="666666"/>
-                </a:solidFill>
-                <a:latin typeface="Arial"/>
-                <a:cs typeface="Arial"/>
-                <a:ea typeface="Calibri"/>
-              </a:rPr>
-              <a:t>Feature Pipeline
-هندسة + تحويل</a:t>
-            </a:r>
-          </a:p>
-        </p:txBody>
-      </p:sp>
-      <p:sp>
-        <p:nvSpPr>
-          <p:cNvPr id="6" name="Left Arrow 5"/>
-          <p:cNvSpPr/>
-          <p:nvPr/>
-        </p:nvSpPr>
-        <p:spPr>
-          <a:xfrm>
-            <a:off x="5468112" y="2331720"/>
-            <a:ext cx="411480" cy="274320"/>
-          </a:xfrm>
-          <a:prstGeom prst="leftArrow">
-            <a:avLst/>
-          </a:prstGeom>
-          <a:solidFill>
-            <a:srgbClr val="1F4E79"/>
-          </a:solidFill>
-          <a:ln>
-            <a:noFill/>
-          </a:ln>
-          <a:effectLst/>
-        </p:spPr>
-        <p:style>
-          <a:lnRef idx="1">
-            <a:schemeClr val="accent1"/>
-          </a:lnRef>
-          <a:fillRef idx="3">
-            <a:schemeClr val="accent1"/>
-          </a:fillRef>
-          <a:effectRef idx="2">
-            <a:schemeClr val="accent1"/>
-          </a:effectRef>
-          <a:fontRef idx="minor">
-            <a:schemeClr val="lt1"/>
-          </a:fontRef>
-        </p:style>
-        <p:txBody>
-          <a:bodyPr rtlCol="0" anchor="ctr"/>
-          <a:lstStyle/>
-          <a:p>
-            <a:pPr algn="ctr"/>
-          </a:p>
-        </p:txBody>
-      </p:sp>
-      <p:sp>
-        <p:nvSpPr>
-          <p:cNvPr id="7" name="Left Arrow 6"/>
-          <p:cNvSpPr/>
-          <p:nvPr/>
-        </p:nvSpPr>
-        <p:spPr>
-          <a:xfrm>
-            <a:off x="5468112" y="3611880"/>
-            <a:ext cx="411480" cy="274320"/>
-          </a:xfrm>
-          <a:prstGeom prst="leftArrow">
-            <a:avLst/>
-          </a:prstGeom>
-          <a:solidFill>
-            <a:srgbClr val="1F4E79"/>
-          </a:solidFill>
-          <a:ln>
-            <a:noFill/>
-          </a:ln>
-          <a:effectLst/>
-        </p:spPr>
-        <p:style>
-          <a:lnRef idx="1">
-            <a:schemeClr val="accent1"/>
-          </a:lnRef>
-          <a:fillRef idx="3">
-            <a:schemeClr val="accent1"/>
-          </a:fillRef>
-          <a:effectRef idx="2">
-            <a:schemeClr val="accent1"/>
-          </a:effectRef>
-          <a:fontRef idx="minor">
-            <a:schemeClr val="lt1"/>
-          </a:fontRef>
-        </p:style>
-        <p:txBody>
-          <a:bodyPr rtlCol="0" anchor="ctr"/>
-          <a:lstStyle/>
-          <a:p>
-            <a:pPr algn="ctr"/>
-          </a:p>
-        </p:txBody>
-      </p:sp>
-      <p:sp>
-        <p:nvSpPr>
-          <p:cNvPr id="8" name="Rounded Rectangle 7"/>
-          <p:cNvSpPr/>
-          <p:nvPr/>
-        </p:nvSpPr>
-        <p:spPr>
-          <a:xfrm>
-            <a:off x="5943600" y="1554480"/>
-            <a:ext cx="2468880" cy="1188720"/>
-          </a:xfrm>
-          <a:prstGeom prst="roundRect">
-            <a:avLst/>
-          </a:prstGeom>
-          <a:solidFill>
-            <a:srgbClr val="E2EFDA"/>
-          </a:solidFill>
-          <a:ln w="12700">
-            <a:solidFill>
-              <a:srgbClr val="1F4E79"/>
-            </a:solidFill>
-          </a:ln>
-          <a:effectLst/>
-        </p:spPr>
-        <p:style>
-          <a:lnRef idx="1">
-            <a:schemeClr val="accent1"/>
-          </a:lnRef>
-          <a:fillRef idx="3">
-            <a:schemeClr val="accent1"/>
-          </a:fillRef>
-          <a:effectRef idx="2">
-            <a:schemeClr val="accent1"/>
-          </a:effectRef>
-          <a:fontRef idx="minor">
-            <a:schemeClr val="lt1"/>
-          </a:fontRef>
-        </p:style>
-        <p:txBody>
-          <a:bodyPr rtlCol="0" anchor="ctr" wrap="square"/>
-          <a:lstStyle/>
-          <a:p>
-            <a:pPr algn="ctr" rtl="1"/>
-            <a:r>
-              <a:rPr sz="1300" b="1">
-                <a:solidFill>
-                  <a:srgbClr val="333333"/>
-                </a:solidFill>
-                <a:latin typeface="Arial"/>
-                <a:cs typeface="Arial"/>
-                <a:ea typeface="Calibri"/>
-              </a:rPr>
-              <a:t>المخزن غير المتصل</a:t>
-            </a:r>
-          </a:p>
-          <a:p>
-            <a:pPr algn="ctr" rtl="1"/>
-            <a:r>
-              <a:rPr sz="1100">
-                <a:solidFill>
-                  <a:srgbClr val="666666"/>
-                </a:solidFill>
-                <a:latin typeface="Arial"/>
-                <a:cs typeface="Arial"/>
-                <a:ea typeface="Calibri"/>
-              </a:rPr>
-              <a:t>Offline Store
-تدريب النماذج</a:t>
-            </a:r>
-          </a:p>
-        </p:txBody>
-      </p:sp>
-      <p:sp>
-        <p:nvSpPr>
-          <p:cNvPr id="9" name="Rounded Rectangle 8"/>
-          <p:cNvSpPr/>
-          <p:nvPr/>
-        </p:nvSpPr>
-        <p:spPr>
-          <a:xfrm>
-            <a:off x="5943600" y="3566160"/>
-            <a:ext cx="2468880" cy="1188720"/>
-          </a:xfrm>
-          <a:prstGeom prst="roundRect">
-            <a:avLst/>
-          </a:prstGeom>
-          <a:solidFill>
-            <a:srgbClr val="FDE9D9"/>
-          </a:solidFill>
-          <a:ln w="12700">
-            <a:solidFill>
-              <a:srgbClr val="1F4E79"/>
-            </a:solidFill>
-          </a:ln>
-          <a:effectLst/>
-        </p:spPr>
-        <p:style>
-          <a:lnRef idx="1">
-            <a:schemeClr val="accent1"/>
-          </a:lnRef>
-          <a:fillRef idx="3">
-            <a:schemeClr val="accent1"/>
-          </a:fillRef>
-          <a:effectRef idx="2">
-            <a:schemeClr val="accent1"/>
-          </a:effectRef>
-          <a:fontRef idx="minor">
-            <a:schemeClr val="lt1"/>
-          </a:fontRef>
-        </p:style>
-        <p:txBody>
-          <a:bodyPr rtlCol="0" anchor="ctr" wrap="square"/>
-          <a:lstStyle/>
-          <a:p>
-            <a:pPr algn="ctr" rtl="1"/>
-            <a:r>
-              <a:rPr sz="1300" b="1">
-                <a:solidFill>
-                  <a:srgbClr val="333333"/>
-                </a:solidFill>
-                <a:latin typeface="Arial"/>
-                <a:cs typeface="Arial"/>
-                <a:ea typeface="Calibri"/>
-              </a:rPr>
-              <a:t>المخزن المتصل</a:t>
-            </a:r>
-          </a:p>
-          <a:p>
-            <a:pPr algn="ctr" rtl="1"/>
-            <a:r>
-              <a:rPr sz="1100">
-                <a:solidFill>
-                  <a:srgbClr val="666666"/>
-                </a:solidFill>
-                <a:latin typeface="Arial"/>
-                <a:cs typeface="Arial"/>
-                <a:ea typeface="Calibri"/>
-              </a:rPr>
-              <a:t>Online Store
-استدلال منخفض زمن الاستجابة</a:t>
-            </a:r>
-          </a:p>
-        </p:txBody>
-      </p:sp>
-      <p:sp>
-        <p:nvSpPr>
-          <p:cNvPr id="10" name="Rounded Rectangle 9"/>
-          <p:cNvSpPr/>
-          <p:nvPr/>
-        </p:nvSpPr>
-        <p:spPr>
-          <a:xfrm>
-            <a:off x="9144000" y="1554480"/>
-            <a:ext cx="2194560" cy="1188720"/>
-          </a:xfrm>
-          <a:prstGeom prst="roundRect">
-            <a:avLst/>
-          </a:prstGeom>
-          <a:solidFill>
-            <a:srgbClr val="EDEDED"/>
-          </a:solidFill>
-          <a:ln w="12700">
-            <a:solidFill>
-              <a:srgbClr val="1F4E79"/>
-            </a:solidFill>
-          </a:ln>
-          <a:effectLst/>
-        </p:spPr>
-        <p:style>
-          <a:lnRef idx="1">
-            <a:schemeClr val="accent1"/>
-          </a:lnRef>
-          <a:fillRef idx="3">
-            <a:schemeClr val="accent1"/>
-          </a:fillRef>
-          <a:effectRef idx="2">
-            <a:schemeClr val="accent1"/>
-          </a:effectRef>
-          <a:fontRef idx="minor">
-            <a:schemeClr val="lt1"/>
-          </a:fontRef>
-        </p:style>
-        <p:txBody>
-          <a:bodyPr rtlCol="0" anchor="ctr" wrap="square"/>
-          <a:lstStyle/>
-          <a:p>
-            <a:pPr algn="ctr" rtl="1"/>
-            <a:r>
-              <a:rPr sz="1400" b="1">
-                <a:solidFill>
-                  <a:srgbClr val="333333"/>
-                </a:solidFill>
-                <a:latin typeface="Arial"/>
-                <a:cs typeface="Arial"/>
-                <a:ea typeface="Calibri"/>
-              </a:rPr>
-              <a:t>التدريب</a:t>
-            </a:r>
-          </a:p>
-          <a:p>
-            <a:pPr algn="ctr" rtl="0"/>
-            <a:r>
-              <a:rPr sz="1100">
-                <a:solidFill>
-                  <a:srgbClr val="666666"/>
-                </a:solidFill>
-                <a:latin typeface="Calibri"/>
-                <a:cs typeface="Arial"/>
-                <a:ea typeface="Calibri"/>
-              </a:rPr>
-              <a:t>Training</a:t>
-            </a:r>
-          </a:p>
-        </p:txBody>
-      </p:sp>
-      <p:sp>
-        <p:nvSpPr>
-          <p:cNvPr id="11" name="Rounded Rectangle 10"/>
-          <p:cNvSpPr/>
-          <p:nvPr/>
-        </p:nvSpPr>
-        <p:spPr>
-          <a:xfrm>
-            <a:off x="9144000" y="3566160"/>
-            <a:ext cx="2194560" cy="1188720"/>
-          </a:xfrm>
-          <a:prstGeom prst="roundRect">
-            <a:avLst/>
-          </a:prstGeom>
-          <a:solidFill>
-            <a:srgbClr val="EDEDED"/>
-          </a:solidFill>
-          <a:ln w="12700">
-            <a:solidFill>
-              <a:srgbClr val="1F4E79"/>
-            </a:solidFill>
-          </a:ln>
-          <a:effectLst/>
-        </p:spPr>
-        <p:style>
-          <a:lnRef idx="1">
-            <a:schemeClr val="accent1"/>
-          </a:lnRef>
-          <a:fillRef idx="3">
-            <a:schemeClr val="accent1"/>
-          </a:fillRef>
-          <a:effectRef idx="2">
-            <a:schemeClr val="accent1"/>
-          </a:effectRef>
-          <a:fontRef idx="minor">
-            <a:schemeClr val="lt1"/>
-          </a:fontRef>
-        </p:style>
-        <p:txBody>
-          <a:bodyPr rtlCol="0" anchor="ctr" wrap="square"/>
-          <a:lstStyle/>
-          <a:p>
-            <a:pPr algn="ctr" rtl="1"/>
-            <a:r>
-              <a:rPr sz="1400" b="1">
-                <a:solidFill>
-                  <a:srgbClr val="333333"/>
-                </a:solidFill>
-                <a:latin typeface="Arial"/>
-                <a:cs typeface="Arial"/>
-                <a:ea typeface="Calibri"/>
-              </a:rPr>
-              <a:t>الاستدلال</a:t>
-            </a:r>
-          </a:p>
-          <a:p>
-            <a:pPr algn="ctr" rtl="0"/>
-            <a:r>
-              <a:rPr sz="1100">
-                <a:solidFill>
-                  <a:srgbClr val="666666"/>
-                </a:solidFill>
-                <a:latin typeface="Calibri"/>
-                <a:cs typeface="Arial"/>
-                <a:ea typeface="Calibri"/>
-              </a:rPr>
-              <a:t>Serving</a:t>
-            </a:r>
-          </a:p>
-        </p:txBody>
-      </p:sp>
-      <p:sp>
-        <p:nvSpPr>
-          <p:cNvPr id="12" name="Left Arrow 11"/>
-          <p:cNvSpPr/>
-          <p:nvPr/>
-        </p:nvSpPr>
-        <p:spPr>
-          <a:xfrm>
-            <a:off x="8449056" y="2011680"/>
-            <a:ext cx="658368" cy="274320"/>
-          </a:xfrm>
-          <a:prstGeom prst="leftArrow">
-            <a:avLst/>
-          </a:prstGeom>
-          <a:solidFill>
-            <a:srgbClr val="1F4E79"/>
-          </a:solidFill>
-          <a:ln>
-            <a:noFill/>
-          </a:ln>
-          <a:effectLst/>
-        </p:spPr>
-        <p:style>
-          <a:lnRef idx="1">
-            <a:schemeClr val="accent1"/>
-          </a:lnRef>
-          <a:fillRef idx="3">
-            <a:schemeClr val="accent1"/>
-          </a:fillRef>
-          <a:effectRef idx="2">
-            <a:schemeClr val="accent1"/>
-          </a:effectRef>
-          <a:fontRef idx="minor">
-            <a:schemeClr val="lt1"/>
-          </a:fontRef>
-        </p:style>
-        <p:txBody>
-          <a:bodyPr rtlCol="0" anchor="ctr"/>
-          <a:lstStyle/>
-          <a:p>
-            <a:pPr algn="ctr"/>
-          </a:p>
-        </p:txBody>
-      </p:sp>
-      <p:sp>
-        <p:nvSpPr>
-          <p:cNvPr id="13" name="Left Arrow 12"/>
-          <p:cNvSpPr/>
-          <p:nvPr/>
-        </p:nvSpPr>
-        <p:spPr>
-          <a:xfrm>
-            <a:off x="8449056" y="4023360"/>
-            <a:ext cx="658368" cy="274320"/>
-          </a:xfrm>
-          <a:prstGeom prst="leftArrow">
-            <a:avLst/>
-          </a:prstGeom>
-          <a:solidFill>
-            <a:srgbClr val="1F4E79"/>
-          </a:solidFill>
-          <a:ln>
-            <a:noFill/>
-          </a:ln>
-          <a:effectLst/>
-        </p:spPr>
-        <p:style>
-          <a:lnRef idx="1">
-            <a:schemeClr val="accent1"/>
-          </a:lnRef>
-          <a:fillRef idx="3">
-            <a:schemeClr val="accent1"/>
-          </a:fillRef>
-          <a:effectRef idx="2">
-            <a:schemeClr val="accent1"/>
-          </a:effectRef>
-          <a:fontRef idx="minor">
-            <a:schemeClr val="lt1"/>
-          </a:fontRef>
-        </p:style>
-        <p:txBody>
-          <a:bodyPr rtlCol="0" anchor="ctr"/>
-          <a:lstStyle/>
-          <a:p>
-            <a:pPr algn="ctr"/>
-          </a:p>
-        </p:txBody>
-      </p:sp>
-      <p:sp>
-        <p:nvSpPr>
-          <p:cNvPr id="14" name="TextBox 13"/>
+          <p:cNvPr id="3" name="TextBox 2"/>
           <p:cNvSpPr txBox="1"/>
           <p:nvPr/>
         </p:nvSpPr>
         <p:spPr>
           <a:xfrm>
-            <a:off x="640080" y="6126480"/>
-            <a:ext cx="10972800" cy="548640"/>
+            <a:off x="640080" y="182880"/>
+            <a:ext cx="10972800" cy="640080"/>
           </a:xfrm>
           <a:prstGeom prst="rect">
             <a:avLst/>
@@ -6480,40 +5350,27 @@
           <a:p>
             <a:pPr algn="r" rtl="1"/>
             <a:r>
-              <a:rPr sz="1400">
-                <a:solidFill>
-                  <a:srgbClr val="666666"/>
+              <a:rPr sz="3200" b="1">
+                <a:solidFill>
+                  <a:srgbClr val="1F3B5C"/>
                 </a:solidFill>
                 <a:latin typeface="Arial"/>
-                <a:cs typeface="Arial"/>
-                <a:ea typeface="Calibri"/>
-              </a:rPr>
-              <a:t>قيمة مخزن الخصائص: نفس تعريف الخصائص للتدريب والاستدلال — لا انحراف.</a:t>
-            </a:r>
-          </a:p>
-          <a:p>
-            <a:pPr algn="r" rtl="0"/>
-            <a:r>
-              <a:rPr>
-                <a:latin typeface="Calibri"/>
-                <a:cs typeface="Arial"/>
-                <a:ea typeface="Calibri"/>
-              </a:rPr>
-              <a:t>Core value: one feature definition for training and serving — no skew.</a:t>
-            </a:r>
-          </a:p>
-        </p:txBody>
-      </p:sp>
-      <p:sp>
-        <p:nvSpPr>
-          <p:cNvPr id="15" name="TextBox 14"/>
+              </a:rPr>
+              <a:t>الربط بالتطبيقات الوكيلة / Agentic Applications</a:t>
+            </a:r>
+          </a:p>
+        </p:txBody>
+      </p:sp>
+      <p:sp>
+        <p:nvSpPr>
+          <p:cNvPr id="4" name="TextBox 3"/>
           <p:cNvSpPr txBox="1"/>
           <p:nvPr/>
         </p:nvSpPr>
         <p:spPr>
           <a:xfrm>
-            <a:off x="640080" y="6400800"/>
-            <a:ext cx="8686800" cy="320040"/>
+            <a:off x="640080" y="1280160"/>
+            <a:ext cx="10972800" cy="5212080"/>
           </a:xfrm>
           <a:prstGeom prst="rect">
             <a:avLst/>
@@ -6526,31 +5383,93 @@
           </a:bodyPr>
           <a:lstStyle/>
           <a:p>
-            <a:pPr algn="r" rtl="1"/>
-            <a:r>
-              <a:rPr sz="1000" b="0">
+            <a:pPr algn="r" rtl="1">
+              <a:spcBef>
+                <a:spcPts val="200"/>
+              </a:spcBef>
+              <a:spcAft>
+                <a:spcPts val="1000"/>
+              </a:spcAft>
+            </a:pPr>
+            <a:r>
+              <a:rPr sz="1900">
+                <a:solidFill>
+                  <a:srgbClr val="333333"/>
+                </a:solidFill>
+                <a:latin typeface="Arial"/>
+              </a:rPr>
+              <a:t>• الوكلاء يحتاجون ميزات لحظية متسقة لقرارات التخصيص والمخاطر والتوجيه.</a:t>
+            </a:r>
+          </a:p>
+          <a:p>
+            <a:pPr algn="l" rtl="0">
+              <a:spcBef>
+                <a:spcPts val="200"/>
+              </a:spcBef>
+              <a:spcAft>
+                <a:spcPts val="1000"/>
+              </a:spcAft>
+            </a:pPr>
+            <a:r>
+              <a:rPr sz="1600">
                 <a:solidFill>
                   <a:srgbClr val="666666"/>
                 </a:solidFill>
+                <a:latin typeface="Calibri"/>
+              </a:rPr>
+              <a:t>• Agents need consistent real-time features for personalization, risk, and routing.</a:t>
+            </a:r>
+          </a:p>
+          <a:p>
+            <a:pPr algn="r" rtl="1">
+              <a:spcBef>
+                <a:spcPts val="200"/>
+              </a:spcBef>
+              <a:spcAft>
+                <a:spcPts val="1000"/>
+              </a:spcAft>
+            </a:pPr>
+            <a:r>
+              <a:rPr sz="1900">
+                <a:solidFill>
+                  <a:srgbClr val="333333"/>
+                </a:solidFill>
                 <a:latin typeface="Arial"/>
-                <a:cs typeface="Arial"/>
-                <a:ea typeface="Calibri"/>
-              </a:rPr>
-              <a:t>Module 02 — Data &amp; AI Engineering Track  |  الوحدة الثانية</a:t>
-            </a:r>
-          </a:p>
-        </p:txBody>
-      </p:sp>
-      <p:sp>
-        <p:nvSpPr>
-          <p:cNvPr id="16" name="TextBox 15"/>
+              </a:rPr>
+              <a:t>• مخزن الخصائص هو «مصدر الحقيقة» للميزات أمام أي وكيل ذكي.</a:t>
+            </a:r>
+          </a:p>
+          <a:p>
+            <a:pPr algn="l" rtl="0">
+              <a:spcBef>
+                <a:spcPts val="200"/>
+              </a:spcBef>
+              <a:spcAft>
+                <a:spcPts val="1000"/>
+              </a:spcAft>
+            </a:pPr>
+            <a:r>
+              <a:rPr sz="1600">
+                <a:solidFill>
+                  <a:srgbClr val="666666"/>
+                </a:solidFill>
+                <a:latin typeface="Calibri"/>
+              </a:rPr>
+              <a:t>• The feature store is the single source of truth behind any agent.</a:t>
+            </a:r>
+          </a:p>
+        </p:txBody>
+      </p:sp>
+      <p:sp>
+        <p:nvSpPr>
+          <p:cNvPr id="5" name="TextBox 4"/>
           <p:cNvSpPr txBox="1"/>
           <p:nvPr/>
         </p:nvSpPr>
         <p:spPr>
           <a:xfrm>
-            <a:off x="9601200" y="6400800"/>
-            <a:ext cx="1920240" cy="320040"/>
+            <a:off x="640080" y="6400800"/>
+            <a:ext cx="8686800" cy="320040"/>
           </a:xfrm>
           <a:prstGeom prst="rect">
             <a:avLst/>
@@ -6563,31 +5482,29 @@
           </a:bodyPr>
           <a:lstStyle/>
           <a:p>
-            <a:pPr algn="l" rtl="0"/>
+            <a:pPr algn="r" rtl="1"/>
             <a:r>
               <a:rPr sz="1000" b="0">
                 <a:solidFill>
                   <a:srgbClr val="666666"/>
                 </a:solidFill>
-                <a:latin typeface="Calibri"/>
-                <a:cs typeface="Arial"/>
-                <a:ea typeface="Calibri"/>
-              </a:rPr>
-              <a:t>08_  •  6/10</a:t>
-            </a:r>
-          </a:p>
-        </p:txBody>
-      </p:sp>
-      <p:sp>
-        <p:nvSpPr>
-          <p:cNvPr id="17" name="TextBox 16"/>
+                <a:latin typeface="Arial"/>
+              </a:rPr>
+              <a:t>Module 02 — Data &amp; AI Engineering Track  |  الوحدة الثانية</a:t>
+            </a:r>
+          </a:p>
+        </p:txBody>
+      </p:sp>
+      <p:sp>
+        <p:nvSpPr>
+          <p:cNvPr id="6" name="TextBox 5"/>
           <p:cNvSpPr txBox="1"/>
           <p:nvPr/>
         </p:nvSpPr>
         <p:spPr>
           <a:xfrm>
-            <a:off x="640080" y="6400800"/>
-            <a:ext cx="8686800" cy="320040"/>
+            <a:off x="9601200" y="6400800"/>
+            <a:ext cx="1920240" cy="320040"/>
           </a:xfrm>
           <a:prstGeom prst="rect">
             <a:avLst/>
@@ -6600,54 +5517,15 @@
           </a:bodyPr>
           <a:lstStyle/>
           <a:p>
-            <a:pPr algn="r" rtl="1"/>
+            <a:pPr algn="l" rtl="0"/>
             <a:r>
               <a:rPr sz="1000" b="0">
                 <a:solidFill>
                   <a:srgbClr val="666666"/>
                 </a:solidFill>
-                <a:latin typeface="Arial"/>
-                <a:cs typeface="Arial"/>
-                <a:ea typeface="Calibri"/>
-              </a:rPr>
-              <a:t>Module 02 — Data &amp; AI Engineering Track  |  الوحدة الثانية</a:t>
-            </a:r>
-          </a:p>
-        </p:txBody>
-      </p:sp>
-      <p:sp>
-        <p:nvSpPr>
-          <p:cNvPr id="18" name="TextBox 17"/>
-          <p:cNvSpPr txBox="1"/>
-          <p:nvPr/>
-        </p:nvSpPr>
-        <p:spPr>
-          <a:xfrm>
-            <a:off x="9601200" y="6400800"/>
-            <a:ext cx="1920240" cy="320040"/>
-          </a:xfrm>
-          <a:prstGeom prst="rect">
-            <a:avLst/>
-          </a:prstGeom>
-          <a:noFill/>
-        </p:spPr>
-        <p:txBody>
-          <a:bodyPr wrap="square">
-            <a:spAutoFit/>
-          </a:bodyPr>
-          <a:lstStyle/>
-          <a:p>
-            <a:pPr algn="l" rtl="0"/>
-            <a:r>
-              <a:rPr sz="1000" b="0">
-                <a:solidFill>
-                  <a:srgbClr val="666666"/>
-                </a:solidFill>
                 <a:latin typeface="Calibri"/>
-                <a:cs typeface="Arial"/>
-                <a:ea typeface="Calibri"/>
-              </a:rPr>
-              <a:t>08_  •  6/10</a:t>
+              </a:rPr>
+              <a:t>V08  •  7/10</a:t>
             </a:r>
           </a:p>
         </p:txBody>
@@ -6753,10 +5631,8 @@
                   <a:srgbClr val="1F3B5C"/>
                 </a:solidFill>
                 <a:latin typeface="Arial"/>
-                <a:cs typeface="Arial"/>
-                <a:ea typeface="Calibri"/>
-              </a:rPr>
-              <a:t>الربط بالتطبيقات الوكيلة / Agentic Applications</a:t>
+              </a:rPr>
+              <a:t>اختبار قصير / Quick Quiz</a:t>
             </a:r>
           </a:p>
         </p:txBody>
@@ -6792,19 +5668,17 @@
               </a:spcAft>
             </a:pPr>
             <a:r>
-              <a:rPr sz="1900">
+              <a:rPr sz="2000">
                 <a:solidFill>
                   <a:srgbClr val="333333"/>
                 </a:solidFill>
                 <a:latin typeface="Arial"/>
-                <a:cs typeface="Arial"/>
-                <a:ea typeface="Calibri"/>
-              </a:rPr>
-              <a:t>• الوكلاء يحتاجون ميزات لحظية متسقة لقرارات التخصيص والمخاطر والتوجيه.</a:t>
-            </a:r>
-          </a:p>
-          <a:p>
-            <a:pPr algn="r" rtl="0">
+              </a:rPr>
+              <a:t>• 1. ما المشكلة التي يحلها مخزن الخصائص؟</a:t>
+            </a:r>
+          </a:p>
+          <a:p>
+            <a:pPr algn="l" rtl="0">
               <a:spcBef>
                 <a:spcPts val="200"/>
               </a:spcBef>
@@ -6813,15 +5687,13 @@
               </a:spcAft>
             </a:pPr>
             <a:r>
-              <a:rPr sz="1600">
+              <a:rPr sz="1700">
                 <a:solidFill>
                   <a:srgbClr val="666666"/>
                 </a:solidFill>
                 <a:latin typeface="Calibri"/>
-                <a:cs typeface="Arial"/>
-                <a:ea typeface="Calibri"/>
-              </a:rPr>
-              <a:t>• Agents need consistent real-time features for personalization, risk, and routing.</a:t>
+              </a:rPr>
+              <a:t>• What problem does a feature store solve?</a:t>
             </a:r>
           </a:p>
           <a:p>
@@ -6834,19 +5706,17 @@
               </a:spcAft>
             </a:pPr>
             <a:r>
-              <a:rPr sz="1900">
+              <a:rPr sz="2000">
                 <a:solidFill>
                   <a:srgbClr val="333333"/>
                 </a:solidFill>
                 <a:latin typeface="Arial"/>
-                <a:cs typeface="Arial"/>
-                <a:ea typeface="Calibri"/>
-              </a:rPr>
-              <a:t>• مخزن الخصائص هو «مصدر الحقيقة» للميزات أمام أي وكيل ذكي.</a:t>
-            </a:r>
-          </a:p>
-          <a:p>
-            <a:pPr algn="r" rtl="0">
+              </a:rPr>
+              <a:t>• 2. فرّق بين المخزن Offline وOnline.</a:t>
+            </a:r>
+          </a:p>
+          <a:p>
+            <a:pPr algn="l" rtl="0">
               <a:spcBef>
                 <a:spcPts val="200"/>
               </a:spcBef>
@@ -6855,15 +5725,51 @@
               </a:spcAft>
             </a:pPr>
             <a:r>
-              <a:rPr sz="1600">
+              <a:rPr sz="1700">
                 <a:solidFill>
                   <a:srgbClr val="666666"/>
                 </a:solidFill>
                 <a:latin typeface="Calibri"/>
-                <a:cs typeface="Arial"/>
-                <a:ea typeface="Calibri"/>
-              </a:rPr>
-              <a:t>• The feature store is the single source of truth behind any agent.</a:t>
+              </a:rPr>
+              <a:t>• Differentiate offline vs online stores.</a:t>
+            </a:r>
+          </a:p>
+          <a:p>
+            <a:pPr algn="r" rtl="1">
+              <a:spcBef>
+                <a:spcPts val="200"/>
+              </a:spcBef>
+              <a:spcAft>
+                <a:spcPts val="1000"/>
+              </a:spcAft>
+            </a:pPr>
+            <a:r>
+              <a:rPr sz="2000">
+                <a:solidFill>
+                  <a:srgbClr val="333333"/>
+                </a:solidFill>
+                <a:latin typeface="Arial"/>
+              </a:rPr>
+              <a:t>• 3. اذكر أداتين لمخازن الخصائص.</a:t>
+            </a:r>
+          </a:p>
+          <a:p>
+            <a:pPr algn="l" rtl="0">
+              <a:spcBef>
+                <a:spcPts val="200"/>
+              </a:spcBef>
+              <a:spcAft>
+                <a:spcPts val="1000"/>
+              </a:spcAft>
+            </a:pPr>
+            <a:r>
+              <a:rPr sz="1700">
+                <a:solidFill>
+                  <a:srgbClr val="666666"/>
+                </a:solidFill>
+                <a:latin typeface="Calibri"/>
+              </a:rPr>
+              <a:t>• Name two feature-store tools.</a:t>
             </a:r>
           </a:p>
         </p:txBody>
@@ -6897,8 +5803,6 @@
                   <a:srgbClr val="666666"/>
                 </a:solidFill>
                 <a:latin typeface="Arial"/>
-                <a:cs typeface="Arial"/>
-                <a:ea typeface="Calibri"/>
               </a:rPr>
               <a:t>Module 02 — Data &amp; AI Engineering Track  |  الوحدة الثانية</a:t>
             </a:r>
@@ -6934,158 +5838,8 @@
                   <a:srgbClr val="666666"/>
                 </a:solidFill>
                 <a:latin typeface="Calibri"/>
-                <a:cs typeface="Arial"/>
-                <a:ea typeface="Calibri"/>
-              </a:rPr>
-              <a:t>V08  •  6/12</a:t>
-            </a:r>
-          </a:p>
-        </p:txBody>
-      </p:sp>
-      <p:sp>
-        <p:nvSpPr>
-          <p:cNvPr id="7" name="TextBox 6"/>
-          <p:cNvSpPr txBox="1"/>
-          <p:nvPr/>
-        </p:nvSpPr>
-        <p:spPr>
-          <a:xfrm>
-            <a:off x="640080" y="6400800"/>
-            <a:ext cx="8686800" cy="320040"/>
-          </a:xfrm>
-          <a:prstGeom prst="rect">
-            <a:avLst/>
-          </a:prstGeom>
-          <a:noFill/>
-        </p:spPr>
-        <p:txBody>
-          <a:bodyPr wrap="square">
-            <a:spAutoFit/>
-          </a:bodyPr>
-          <a:lstStyle/>
-          <a:p>
-            <a:pPr algn="r" rtl="1"/>
-            <a:r>
-              <a:rPr sz="1000" b="0">
-                <a:solidFill>
-                  <a:srgbClr val="666666"/>
-                </a:solidFill>
-                <a:latin typeface="Arial"/>
-                <a:cs typeface="Arial"/>
-                <a:ea typeface="Calibri"/>
-              </a:rPr>
-              <a:t>Module 02 — Data &amp; AI Engineering Track  |  الوحدة الثانية</a:t>
-            </a:r>
-          </a:p>
-        </p:txBody>
-      </p:sp>
-      <p:sp>
-        <p:nvSpPr>
-          <p:cNvPr id="8" name="TextBox 7"/>
-          <p:cNvSpPr txBox="1"/>
-          <p:nvPr/>
-        </p:nvSpPr>
-        <p:spPr>
-          <a:xfrm>
-            <a:off x="9601200" y="6400800"/>
-            <a:ext cx="1920240" cy="320040"/>
-          </a:xfrm>
-          <a:prstGeom prst="rect">
-            <a:avLst/>
-          </a:prstGeom>
-          <a:noFill/>
-        </p:spPr>
-        <p:txBody>
-          <a:bodyPr wrap="square">
-            <a:spAutoFit/>
-          </a:bodyPr>
-          <a:lstStyle/>
-          <a:p>
-            <a:pPr algn="l" rtl="0"/>
-            <a:r>
-              <a:rPr sz="1000" b="0">
-                <a:solidFill>
-                  <a:srgbClr val="666666"/>
-                </a:solidFill>
-                <a:latin typeface="Calibri"/>
-                <a:cs typeface="Arial"/>
-                <a:ea typeface="Calibri"/>
-              </a:rPr>
-              <a:t>08_  •  7/10</a:t>
-            </a:r>
-          </a:p>
-        </p:txBody>
-      </p:sp>
-      <p:sp>
-        <p:nvSpPr>
-          <p:cNvPr id="9" name="TextBox 8"/>
-          <p:cNvSpPr txBox="1"/>
-          <p:nvPr/>
-        </p:nvSpPr>
-        <p:spPr>
-          <a:xfrm>
-            <a:off x="640080" y="6400800"/>
-            <a:ext cx="8686800" cy="320040"/>
-          </a:xfrm>
-          <a:prstGeom prst="rect">
-            <a:avLst/>
-          </a:prstGeom>
-          <a:noFill/>
-        </p:spPr>
-        <p:txBody>
-          <a:bodyPr wrap="square">
-            <a:spAutoFit/>
-          </a:bodyPr>
-          <a:lstStyle/>
-          <a:p>
-            <a:pPr algn="r" rtl="1"/>
-            <a:r>
-              <a:rPr sz="1000" b="0">
-                <a:solidFill>
-                  <a:srgbClr val="666666"/>
-                </a:solidFill>
-                <a:latin typeface="Arial"/>
-                <a:cs typeface="Arial"/>
-                <a:ea typeface="Calibri"/>
-              </a:rPr>
-              <a:t>Module 02 — Data &amp; AI Engineering Track  |  الوحدة الثانية</a:t>
-            </a:r>
-          </a:p>
-        </p:txBody>
-      </p:sp>
-      <p:sp>
-        <p:nvSpPr>
-          <p:cNvPr id="10" name="TextBox 9"/>
-          <p:cNvSpPr txBox="1"/>
-          <p:nvPr/>
-        </p:nvSpPr>
-        <p:spPr>
-          <a:xfrm>
-            <a:off x="9601200" y="6400800"/>
-            <a:ext cx="1920240" cy="320040"/>
-          </a:xfrm>
-          <a:prstGeom prst="rect">
-            <a:avLst/>
-          </a:prstGeom>
-          <a:noFill/>
-        </p:spPr>
-        <p:txBody>
-          <a:bodyPr wrap="square">
-            <a:spAutoFit/>
-          </a:bodyPr>
-          <a:lstStyle/>
-          <a:p>
-            <a:pPr algn="l" rtl="0"/>
-            <a:r>
-              <a:rPr sz="1000" b="0">
-                <a:solidFill>
-                  <a:srgbClr val="666666"/>
-                </a:solidFill>
-                <a:latin typeface="Calibri"/>
-                <a:cs typeface="Arial"/>
-                <a:ea typeface="Calibri"/>
-              </a:rPr>
-              <a:t>08_  •  7/10</a:t>
+              </a:rPr>
+              <a:t>V08  •  8/10</a:t>
             </a:r>
           </a:p>
         </p:txBody>
@@ -7191,10 +5945,8 @@
                   <a:srgbClr val="1F3B5C"/>
                 </a:solidFill>
                 <a:latin typeface="Arial"/>
-                <a:cs typeface="Arial"/>
-                <a:ea typeface="Calibri"/>
-              </a:rPr>
-              <a:t>اختبار قصير / Quick Quiz</a:t>
+              </a:rPr>
+              <a:t>إجابات الاختبار / Quiz Answers</a:t>
             </a:r>
           </a:p>
         </p:txBody>
@@ -7230,19 +5982,17 @@
               </a:spcAft>
             </a:pPr>
             <a:r>
-              <a:rPr sz="2000">
+              <a:rPr sz="1800">
                 <a:solidFill>
                   <a:srgbClr val="333333"/>
                 </a:solidFill>
                 <a:latin typeface="Arial"/>
-                <a:cs typeface="Arial"/>
-                <a:ea typeface="Calibri"/>
-              </a:rPr>
-              <a:t>• 1. ما المشكلة التي يحلها مخزن الخصائص؟</a:t>
-            </a:r>
-          </a:p>
-          <a:p>
-            <a:pPr algn="r" rtl="0">
+              </a:rPr>
+              <a:t>• 1. انحراف الميزات بين التدريب والخدمة وتكرار العمل.</a:t>
+            </a:r>
+          </a:p>
+          <a:p>
+            <a:pPr algn="l" rtl="0">
               <a:spcBef>
                 <a:spcPts val="200"/>
               </a:spcBef>
@@ -7251,15 +6001,13 @@
               </a:spcAft>
             </a:pPr>
             <a:r>
-              <a:rPr sz="1700">
+              <a:rPr sz="1500">
                 <a:solidFill>
                   <a:srgbClr val="666666"/>
                 </a:solidFill>
                 <a:latin typeface="Calibri"/>
-                <a:cs typeface="Arial"/>
-                <a:ea typeface="Calibri"/>
-              </a:rPr>
-              <a:t>• What problem does a feature store solve?</a:t>
+              </a:rPr>
+              <a:t>• Feature skew between training/serving and duplicated work.</a:t>
             </a:r>
           </a:p>
           <a:p>
@@ -7272,19 +6020,17 @@
               </a:spcAft>
             </a:pPr>
             <a:r>
-              <a:rPr sz="2000">
+              <a:rPr sz="1800">
                 <a:solidFill>
                   <a:srgbClr val="333333"/>
                 </a:solidFill>
                 <a:latin typeface="Arial"/>
-                <a:cs typeface="Arial"/>
-                <a:ea typeface="Calibri"/>
-              </a:rPr>
-              <a:t>• 2. فرّق بين المخزن Offline وOnline.</a:t>
-            </a:r>
-          </a:p>
-          <a:p>
-            <a:pPr algn="r" rtl="0">
+              </a:rPr>
+              <a:t>• 2. Offline للتدريب التاريخي؛ Online لخدمة فورية منخفضة الكمون.</a:t>
+            </a:r>
+          </a:p>
+          <a:p>
+            <a:pPr algn="l" rtl="0">
               <a:spcBef>
                 <a:spcPts val="200"/>
               </a:spcBef>
@@ -7293,15 +6039,13 @@
               </a:spcAft>
             </a:pPr>
             <a:r>
-              <a:rPr sz="1700">
+              <a:rPr sz="1500">
                 <a:solidFill>
                   <a:srgbClr val="666666"/>
                 </a:solidFill>
                 <a:latin typeface="Calibri"/>
-                <a:cs typeface="Arial"/>
-                <a:ea typeface="Calibri"/>
-              </a:rPr>
-              <a:t>• Differentiate offline vs online stores.</a:t>
+              </a:rPr>
+              <a:t>• Offline for historical training; online for low-latency serving.</a:t>
             </a:r>
           </a:p>
           <a:p>
@@ -7314,19 +6058,17 @@
               </a:spcAft>
             </a:pPr>
             <a:r>
-              <a:rPr sz="2000">
+              <a:rPr sz="1800">
                 <a:solidFill>
                   <a:srgbClr val="333333"/>
                 </a:solidFill>
                 <a:latin typeface="Arial"/>
-                <a:cs typeface="Arial"/>
-                <a:ea typeface="Calibri"/>
-              </a:rPr>
-              <a:t>• 3. اذكر أداتين لمخازن الخصائص.</a:t>
-            </a:r>
-          </a:p>
-          <a:p>
-            <a:pPr algn="r" rtl="0">
+              </a:rPr>
+              <a:t>• 3. Feast وHopsworks (أو Tecton).</a:t>
+            </a:r>
+          </a:p>
+          <a:p>
+            <a:pPr algn="l" rtl="0">
               <a:spcBef>
                 <a:spcPts val="200"/>
               </a:spcBef>
@@ -7335,15 +6077,13 @@
               </a:spcAft>
             </a:pPr>
             <a:r>
-              <a:rPr sz="1700">
+              <a:rPr sz="1500">
                 <a:solidFill>
                   <a:srgbClr val="666666"/>
                 </a:solidFill>
                 <a:latin typeface="Calibri"/>
-                <a:cs typeface="Arial"/>
-                <a:ea typeface="Calibri"/>
-              </a:rPr>
-              <a:t>• Name two feature-store tools.</a:t>
+              </a:rPr>
+              <a:t>• Feast and Hopsworks (or Tecton).</a:t>
             </a:r>
           </a:p>
         </p:txBody>
@@ -7377,8 +6117,6 @@
                   <a:srgbClr val="666666"/>
                 </a:solidFill>
                 <a:latin typeface="Arial"/>
-                <a:cs typeface="Arial"/>
-                <a:ea typeface="Calibri"/>
               </a:rPr>
               <a:t>Module 02 — Data &amp; AI Engineering Track  |  الوحدة الثانية</a:t>
             </a:r>
@@ -7414,158 +6152,8 @@
                   <a:srgbClr val="666666"/>
                 </a:solidFill>
                 <a:latin typeface="Calibri"/>
-                <a:cs typeface="Arial"/>
-                <a:ea typeface="Calibri"/>
-              </a:rPr>
-              <a:t>V08  •  7/12</a:t>
-            </a:r>
-          </a:p>
-        </p:txBody>
-      </p:sp>
-      <p:sp>
-        <p:nvSpPr>
-          <p:cNvPr id="7" name="TextBox 6"/>
-          <p:cNvSpPr txBox="1"/>
-          <p:nvPr/>
-        </p:nvSpPr>
-        <p:spPr>
-          <a:xfrm>
-            <a:off x="640080" y="6400800"/>
-            <a:ext cx="8686800" cy="320040"/>
-          </a:xfrm>
-          <a:prstGeom prst="rect">
-            <a:avLst/>
-          </a:prstGeom>
-          <a:noFill/>
-        </p:spPr>
-        <p:txBody>
-          <a:bodyPr wrap="square">
-            <a:spAutoFit/>
-          </a:bodyPr>
-          <a:lstStyle/>
-          <a:p>
-            <a:pPr algn="r" rtl="1"/>
-            <a:r>
-              <a:rPr sz="1000" b="0">
-                <a:solidFill>
-                  <a:srgbClr val="666666"/>
-                </a:solidFill>
-                <a:latin typeface="Arial"/>
-                <a:cs typeface="Arial"/>
-                <a:ea typeface="Calibri"/>
-              </a:rPr>
-              <a:t>Module 02 — Data &amp; AI Engineering Track  |  الوحدة الثانية</a:t>
-            </a:r>
-          </a:p>
-        </p:txBody>
-      </p:sp>
-      <p:sp>
-        <p:nvSpPr>
-          <p:cNvPr id="8" name="TextBox 7"/>
-          <p:cNvSpPr txBox="1"/>
-          <p:nvPr/>
-        </p:nvSpPr>
-        <p:spPr>
-          <a:xfrm>
-            <a:off x="9601200" y="6400800"/>
-            <a:ext cx="1920240" cy="320040"/>
-          </a:xfrm>
-          <a:prstGeom prst="rect">
-            <a:avLst/>
-          </a:prstGeom>
-          <a:noFill/>
-        </p:spPr>
-        <p:txBody>
-          <a:bodyPr wrap="square">
-            <a:spAutoFit/>
-          </a:bodyPr>
-          <a:lstStyle/>
-          <a:p>
-            <a:pPr algn="l" rtl="0"/>
-            <a:r>
-              <a:rPr sz="1000" b="0">
-                <a:solidFill>
-                  <a:srgbClr val="666666"/>
-                </a:solidFill>
-                <a:latin typeface="Calibri"/>
-                <a:cs typeface="Arial"/>
-                <a:ea typeface="Calibri"/>
-              </a:rPr>
-              <a:t>08_  •  8/10</a:t>
-            </a:r>
-          </a:p>
-        </p:txBody>
-      </p:sp>
-      <p:sp>
-        <p:nvSpPr>
-          <p:cNvPr id="9" name="TextBox 8"/>
-          <p:cNvSpPr txBox="1"/>
-          <p:nvPr/>
-        </p:nvSpPr>
-        <p:spPr>
-          <a:xfrm>
-            <a:off x="640080" y="6400800"/>
-            <a:ext cx="8686800" cy="320040"/>
-          </a:xfrm>
-          <a:prstGeom prst="rect">
-            <a:avLst/>
-          </a:prstGeom>
-          <a:noFill/>
-        </p:spPr>
-        <p:txBody>
-          <a:bodyPr wrap="square">
-            <a:spAutoFit/>
-          </a:bodyPr>
-          <a:lstStyle/>
-          <a:p>
-            <a:pPr algn="r" rtl="1"/>
-            <a:r>
-              <a:rPr sz="1000" b="0">
-                <a:solidFill>
-                  <a:srgbClr val="666666"/>
-                </a:solidFill>
-                <a:latin typeface="Arial"/>
-                <a:cs typeface="Arial"/>
-                <a:ea typeface="Calibri"/>
-              </a:rPr>
-              <a:t>Module 02 — Data &amp; AI Engineering Track  |  الوحدة الثانية</a:t>
-            </a:r>
-          </a:p>
-        </p:txBody>
-      </p:sp>
-      <p:sp>
-        <p:nvSpPr>
-          <p:cNvPr id="10" name="TextBox 9"/>
-          <p:cNvSpPr txBox="1"/>
-          <p:nvPr/>
-        </p:nvSpPr>
-        <p:spPr>
-          <a:xfrm>
-            <a:off x="9601200" y="6400800"/>
-            <a:ext cx="1920240" cy="320040"/>
-          </a:xfrm>
-          <a:prstGeom prst="rect">
-            <a:avLst/>
-          </a:prstGeom>
-          <a:noFill/>
-        </p:spPr>
-        <p:txBody>
-          <a:bodyPr wrap="square">
-            <a:spAutoFit/>
-          </a:bodyPr>
-          <a:lstStyle/>
-          <a:p>
-            <a:pPr algn="l" rtl="0"/>
-            <a:r>
-              <a:rPr sz="1000" b="0">
-                <a:solidFill>
-                  <a:srgbClr val="666666"/>
-                </a:solidFill>
-                <a:latin typeface="Calibri"/>
-                <a:cs typeface="Arial"/>
-                <a:ea typeface="Calibri"/>
-              </a:rPr>
-              <a:t>08_  •  8/10</a:t>
+              </a:rPr>
+              <a:t>V08  •  9/10</a:t>
             </a:r>
           </a:p>
         </p:txBody>
@@ -7671,10 +6259,8 @@
                   <a:srgbClr val="1F3B5C"/>
                 </a:solidFill>
                 <a:latin typeface="Arial"/>
-                <a:cs typeface="Arial"/>
-                <a:ea typeface="Calibri"/>
-              </a:rPr>
-              <a:t>إجابات الاختبار / Quiz Answers</a:t>
+              </a:rPr>
+              <a:t>للاستزادة / Further Reading</a:t>
             </a:r>
           </a:p>
         </p:txBody>
@@ -7710,19 +6296,17 @@
               </a:spcAft>
             </a:pPr>
             <a:r>
-              <a:rPr sz="1800">
+              <a:rPr sz="2000">
                 <a:solidFill>
                   <a:srgbClr val="333333"/>
                 </a:solidFill>
                 <a:latin typeface="Arial"/>
-                <a:cs typeface="Arial"/>
-                <a:ea typeface="Calibri"/>
-              </a:rPr>
-              <a:t>• 1. انحراف الميزات بين التدريب والخدمة وتكرار العمل.</a:t>
-            </a:r>
-          </a:p>
-          <a:p>
-            <a:pPr algn="r" rtl="0">
+              </a:rPr>
+              <a:t>• توثيق Feast.</a:t>
+            </a:r>
+          </a:p>
+          <a:p>
+            <a:pPr algn="l" rtl="0">
               <a:spcBef>
                 <a:spcPts val="200"/>
               </a:spcBef>
@@ -7731,15 +6315,13 @@
               </a:spcAft>
             </a:pPr>
             <a:r>
-              <a:rPr sz="1500">
+              <a:rPr sz="1700">
                 <a:solidFill>
                   <a:srgbClr val="666666"/>
                 </a:solidFill>
                 <a:latin typeface="Calibri"/>
-                <a:cs typeface="Arial"/>
-                <a:ea typeface="Calibri"/>
-              </a:rPr>
-              <a:t>• Feature skew between training/serving and duplicated work.</a:t>
+              </a:rPr>
+              <a:t>• Feast documentation.</a:t>
             </a:r>
           </a:p>
           <a:p>
@@ -7752,19 +6334,17 @@
               </a:spcAft>
             </a:pPr>
             <a:r>
-              <a:rPr sz="1800">
+              <a:rPr sz="2000">
                 <a:solidFill>
                   <a:srgbClr val="333333"/>
                 </a:solidFill>
                 <a:latin typeface="Arial"/>
-                <a:cs typeface="Arial"/>
-                <a:ea typeface="Calibri"/>
-              </a:rPr>
-              <a:t>• 2. Offline للتدريب التاريخي؛ Online لخدمة فورية منخفضة الكمون.</a:t>
-            </a:r>
-          </a:p>
-          <a:p>
-            <a:pPr algn="r" rtl="0">
+              </a:rPr>
+              <a:t>• توثيق Hopsworks Feature Store.</a:t>
+            </a:r>
+          </a:p>
+          <a:p>
+            <a:pPr algn="l" rtl="0">
               <a:spcBef>
                 <a:spcPts val="200"/>
               </a:spcBef>
@@ -7773,57 +6353,13 @@
               </a:spcAft>
             </a:pPr>
             <a:r>
-              <a:rPr sz="1500">
+              <a:rPr sz="1700">
                 <a:solidFill>
                   <a:srgbClr val="666666"/>
                 </a:solidFill>
                 <a:latin typeface="Calibri"/>
-                <a:cs typeface="Arial"/>
-                <a:ea typeface="Calibri"/>
-              </a:rPr>
-              <a:t>• Offline for historical training; online for low-latency serving.</a:t>
-            </a:r>
-          </a:p>
-          <a:p>
-            <a:pPr algn="r" rtl="1">
-              <a:spcBef>
-                <a:spcPts val="200"/>
-              </a:spcBef>
-              <a:spcAft>
-                <a:spcPts val="1000"/>
-              </a:spcAft>
-            </a:pPr>
-            <a:r>
-              <a:rPr sz="1800">
-                <a:solidFill>
-                  <a:srgbClr val="333333"/>
-                </a:solidFill>
-                <a:latin typeface="Arial"/>
-                <a:cs typeface="Arial"/>
-                <a:ea typeface="Calibri"/>
-              </a:rPr>
-              <a:t>• 3. Feast وHopsworks (أو Tecton).</a:t>
-            </a:r>
-          </a:p>
-          <a:p>
-            <a:pPr algn="r" rtl="0">
-              <a:spcBef>
-                <a:spcPts val="200"/>
-              </a:spcBef>
-              <a:spcAft>
-                <a:spcPts val="1000"/>
-              </a:spcAft>
-            </a:pPr>
-            <a:r>
-              <a:rPr sz="1500">
-                <a:solidFill>
-                  <a:srgbClr val="666666"/>
-                </a:solidFill>
-                <a:latin typeface="Calibri"/>
-                <a:cs typeface="Arial"/>
-                <a:ea typeface="Calibri"/>
-              </a:rPr>
-              <a:t>• Feast and Hopsworks (or Tecton).</a:t>
+              </a:rPr>
+              <a:t>• Hopsworks feature store docs.</a:t>
             </a:r>
           </a:p>
         </p:txBody>
@@ -7857,8 +6393,6 @@
                   <a:srgbClr val="666666"/>
                 </a:solidFill>
                 <a:latin typeface="Arial"/>
-                <a:cs typeface="Arial"/>
-                <a:ea typeface="Calibri"/>
               </a:rPr>
               <a:t>Module 02 — Data &amp; AI Engineering Track  |  الوحدة الثانية</a:t>
             </a:r>
@@ -7894,158 +6428,8 @@
                   <a:srgbClr val="666666"/>
                 </a:solidFill>
                 <a:latin typeface="Calibri"/>
-                <a:cs typeface="Arial"/>
-                <a:ea typeface="Calibri"/>
-              </a:rPr>
-              <a:t>V08  •  8/12</a:t>
-            </a:r>
-          </a:p>
-        </p:txBody>
-      </p:sp>
-      <p:sp>
-        <p:nvSpPr>
-          <p:cNvPr id="7" name="TextBox 6"/>
-          <p:cNvSpPr txBox="1"/>
-          <p:nvPr/>
-        </p:nvSpPr>
-        <p:spPr>
-          <a:xfrm>
-            <a:off x="640080" y="6400800"/>
-            <a:ext cx="8686800" cy="320040"/>
-          </a:xfrm>
-          <a:prstGeom prst="rect">
-            <a:avLst/>
-          </a:prstGeom>
-          <a:noFill/>
-        </p:spPr>
-        <p:txBody>
-          <a:bodyPr wrap="square">
-            <a:spAutoFit/>
-          </a:bodyPr>
-          <a:lstStyle/>
-          <a:p>
-            <a:pPr algn="r" rtl="1"/>
-            <a:r>
-              <a:rPr sz="1000" b="0">
-                <a:solidFill>
-                  <a:srgbClr val="666666"/>
-                </a:solidFill>
-                <a:latin typeface="Arial"/>
-                <a:cs typeface="Arial"/>
-                <a:ea typeface="Calibri"/>
-              </a:rPr>
-              <a:t>Module 02 — Data &amp; AI Engineering Track  |  الوحدة الثانية</a:t>
-            </a:r>
-          </a:p>
-        </p:txBody>
-      </p:sp>
-      <p:sp>
-        <p:nvSpPr>
-          <p:cNvPr id="8" name="TextBox 7"/>
-          <p:cNvSpPr txBox="1"/>
-          <p:nvPr/>
-        </p:nvSpPr>
-        <p:spPr>
-          <a:xfrm>
-            <a:off x="9601200" y="6400800"/>
-            <a:ext cx="1920240" cy="320040"/>
-          </a:xfrm>
-          <a:prstGeom prst="rect">
-            <a:avLst/>
-          </a:prstGeom>
-          <a:noFill/>
-        </p:spPr>
-        <p:txBody>
-          <a:bodyPr wrap="square">
-            <a:spAutoFit/>
-          </a:bodyPr>
-          <a:lstStyle/>
-          <a:p>
-            <a:pPr algn="l" rtl="0"/>
-            <a:r>
-              <a:rPr sz="1000" b="0">
-                <a:solidFill>
-                  <a:srgbClr val="666666"/>
-                </a:solidFill>
-                <a:latin typeface="Calibri"/>
-                <a:cs typeface="Arial"/>
-                <a:ea typeface="Calibri"/>
-              </a:rPr>
-              <a:t>08_  •  9/10</a:t>
-            </a:r>
-          </a:p>
-        </p:txBody>
-      </p:sp>
-      <p:sp>
-        <p:nvSpPr>
-          <p:cNvPr id="9" name="TextBox 8"/>
-          <p:cNvSpPr txBox="1"/>
-          <p:nvPr/>
-        </p:nvSpPr>
-        <p:spPr>
-          <a:xfrm>
-            <a:off x="640080" y="6400800"/>
-            <a:ext cx="8686800" cy="320040"/>
-          </a:xfrm>
-          <a:prstGeom prst="rect">
-            <a:avLst/>
-          </a:prstGeom>
-          <a:noFill/>
-        </p:spPr>
-        <p:txBody>
-          <a:bodyPr wrap="square">
-            <a:spAutoFit/>
-          </a:bodyPr>
-          <a:lstStyle/>
-          <a:p>
-            <a:pPr algn="r" rtl="1"/>
-            <a:r>
-              <a:rPr sz="1000" b="0">
-                <a:solidFill>
-                  <a:srgbClr val="666666"/>
-                </a:solidFill>
-                <a:latin typeface="Arial"/>
-                <a:cs typeface="Arial"/>
-                <a:ea typeface="Calibri"/>
-              </a:rPr>
-              <a:t>Module 02 — Data &amp; AI Engineering Track  |  الوحدة الثانية</a:t>
-            </a:r>
-          </a:p>
-        </p:txBody>
-      </p:sp>
-      <p:sp>
-        <p:nvSpPr>
-          <p:cNvPr id="10" name="TextBox 9"/>
-          <p:cNvSpPr txBox="1"/>
-          <p:nvPr/>
-        </p:nvSpPr>
-        <p:spPr>
-          <a:xfrm>
-            <a:off x="9601200" y="6400800"/>
-            <a:ext cx="1920240" cy="320040"/>
-          </a:xfrm>
-          <a:prstGeom prst="rect">
-            <a:avLst/>
-          </a:prstGeom>
-          <a:noFill/>
-        </p:spPr>
-        <p:txBody>
-          <a:bodyPr wrap="square">
-            <a:spAutoFit/>
-          </a:bodyPr>
-          <a:lstStyle/>
-          <a:p>
-            <a:pPr algn="l" rtl="0"/>
-            <a:r>
-              <a:rPr sz="1000" b="0">
-                <a:solidFill>
-                  <a:srgbClr val="666666"/>
-                </a:solidFill>
-                <a:latin typeface="Calibri"/>
-                <a:cs typeface="Arial"/>
-                <a:ea typeface="Calibri"/>
-              </a:rPr>
-              <a:t>08_  •  9/10</a:t>
+              </a:rPr>
+              <a:t>V08  •  10/10</a:t>
             </a:r>
           </a:p>
         </p:txBody>

</xml_diff>